<commit_message>
docs: enlarge two business-deck panels so their copy is not cramped (T073)
Slide 6's "Deliberately absent" card grows from 104px to 130px and slide 10's ask bar from
128px to 153px; the slide 6 table settles 0.2px taller on re-save. Slide text is unchanged
across all ten slides, so the deck's language guardrails are unaffected.

Note: reports/decks/canvas/build_pptx.py still emits the original heights, so regenerating
the deck from it would revert these two panels.

Claude-Session: https://claude.ai/code/session_01YWigqjn9Pr9kDRf8J6GSvy
</commit_message>
<xml_diff>
--- a/reports/decks/business_deck.pptx
+++ b/reports/decks/business_deck.pptx
@@ -5,18 +5,18 @@
     <p:sldMasterId id="2147483648" r:id="rId1"/>
   </p:sldMasterIdLst>
   <p:sldIdLst>
-    <p:sldId id="256" r:id="rId7"/>
-    <p:sldId id="257" r:id="rId8"/>
-    <p:sldId id="258" r:id="rId9"/>
-    <p:sldId id="259" r:id="rId10"/>
-    <p:sldId id="260" r:id="rId11"/>
-    <p:sldId id="261" r:id="rId12"/>
-    <p:sldId id="262" r:id="rId13"/>
-    <p:sldId id="263" r:id="rId14"/>
-    <p:sldId id="264" r:id="rId15"/>
-    <p:sldId id="265" r:id="rId16"/>
+    <p:sldId id="256" r:id="rId2"/>
+    <p:sldId id="257" r:id="rId3"/>
+    <p:sldId id="258" r:id="rId4"/>
+    <p:sldId id="259" r:id="rId5"/>
+    <p:sldId id="260" r:id="rId6"/>
+    <p:sldId id="261" r:id="rId7"/>
+    <p:sldId id="262" r:id="rId8"/>
+    <p:sldId id="263" r:id="rId9"/>
+    <p:sldId id="264" r:id="rId10"/>
+    <p:sldId id="265" r:id="rId11"/>
   </p:sldIdLst>
-  <p:sldSz cx="12192000" cy="6858000" type="screen4x3"/>
+  <p:sldSz cx="12192000" cy="6858000"/>
   <p:notesSz cx="6858000" cy="9144000"/>
   <p:defaultTextStyle>
     <a:defPPr>
@@ -113,6 +113,22 @@
       </a:defRPr>
     </a:lvl9pPr>
   </p:defaultTextStyle>
+  <p:extLst>
+    <p:ext uri="{EFAFB233-063F-42B5-8137-9DF3F51BA10A}">
+      <p15:sldGuideLst xmlns:p15="http://schemas.microsoft.com/office/powerpoint/2012/main">
+        <p15:guide id="1" orient="horz" pos="2160">
+          <p15:clr>
+            <a:srgbClr val="A4A3A4"/>
+          </p15:clr>
+        </p15:guide>
+        <p15:guide id="2" pos="2880">
+          <p15:clr>
+            <a:srgbClr val="A4A3A4"/>
+          </p15:clr>
+        </p15:guide>
+      </p15:sldGuideLst>
+    </p:ext>
+  </p:extLst>
 </p:presentation>
 </file>
 
@@ -154,10 +170,9 @@
           <a:lstStyle/>
           <a:p>
             <a:r>
-              <a:rPr lang="en-US" smtClean="0"/>
+              <a:rPr lang="en-US"/>
               <a:t>Click to edit Master title style</a:t>
             </a:r>
-            <a:endParaRPr lang="en-US"/>
           </a:p>
         </p:txBody>
       </p:sp>
@@ -273,10 +288,9 @@
           </a:lstStyle>
           <a:p>
             <a:r>
-              <a:rPr lang="en-US" smtClean="0"/>
+              <a:rPr lang="en-US"/>
               <a:t>Click to edit Master subtitle style</a:t>
             </a:r>
-            <a:endParaRPr lang="en-US"/>
           </a:p>
         </p:txBody>
       </p:sp>
@@ -297,7 +311,7 @@
           <a:p>
             <a:fld id="{5BCAD085-E8A6-8845-BD4E-CB4CCA059FC4}" type="datetimeFigureOut">
               <a:rPr lang="en-US" smtClean="0"/>
-              <a:t>1/27/13</a:t>
+              <a:t>9/11/26</a:t>
             </a:fld>
             <a:endParaRPr lang="en-US"/>
           </a:p>
@@ -391,10 +405,9 @@
           <a:lstStyle/>
           <a:p>
             <a:r>
-              <a:rPr lang="en-US" smtClean="0"/>
+              <a:rPr lang="en-US"/>
               <a:t>Click to edit Master title style</a:t>
             </a:r>
-            <a:endParaRPr lang="en-US"/>
           </a:p>
         </p:txBody>
       </p:sp>
@@ -415,38 +428,37 @@
           <a:p>
             <a:pPr lvl="0"/>
             <a:r>
-              <a:rPr lang="en-US" smtClean="0"/>
+              <a:rPr lang="en-US"/>
               <a:t>Click to edit Master text styles</a:t>
             </a:r>
           </a:p>
           <a:p>
             <a:pPr lvl="1"/>
             <a:r>
-              <a:rPr lang="en-US" smtClean="0"/>
+              <a:rPr lang="en-US"/>
               <a:t>Second level</a:t>
             </a:r>
           </a:p>
           <a:p>
             <a:pPr lvl="2"/>
             <a:r>
-              <a:rPr lang="en-US" smtClean="0"/>
+              <a:rPr lang="en-US"/>
               <a:t>Third level</a:t>
             </a:r>
           </a:p>
           <a:p>
             <a:pPr lvl="3"/>
             <a:r>
-              <a:rPr lang="en-US" smtClean="0"/>
+              <a:rPr lang="en-US"/>
               <a:t>Fourth level</a:t>
             </a:r>
           </a:p>
           <a:p>
             <a:pPr lvl="4"/>
             <a:r>
-              <a:rPr lang="en-US" smtClean="0"/>
+              <a:rPr lang="en-US"/>
               <a:t>Fifth level</a:t>
             </a:r>
-            <a:endParaRPr lang="en-US"/>
           </a:p>
         </p:txBody>
       </p:sp>
@@ -467,7 +479,7 @@
           <a:p>
             <a:fld id="{5BCAD085-E8A6-8845-BD4E-CB4CCA059FC4}" type="datetimeFigureOut">
               <a:rPr lang="en-US" smtClean="0"/>
-              <a:t>1/27/13</a:t>
+              <a:t>9/11/26</a:t>
             </a:fld>
             <a:endParaRPr lang="en-US"/>
           </a:p>
@@ -566,10 +578,9 @@
           <a:lstStyle/>
           <a:p>
             <a:r>
-              <a:rPr lang="en-US" smtClean="0"/>
+              <a:rPr lang="en-US"/>
               <a:t>Click to edit Master title style</a:t>
             </a:r>
-            <a:endParaRPr lang="en-US"/>
           </a:p>
         </p:txBody>
       </p:sp>
@@ -595,38 +606,37 @@
           <a:p>
             <a:pPr lvl="0"/>
             <a:r>
-              <a:rPr lang="en-US" smtClean="0"/>
+              <a:rPr lang="en-US"/>
               <a:t>Click to edit Master text styles</a:t>
             </a:r>
           </a:p>
           <a:p>
             <a:pPr lvl="1"/>
             <a:r>
-              <a:rPr lang="en-US" smtClean="0"/>
+              <a:rPr lang="en-US"/>
               <a:t>Second level</a:t>
             </a:r>
           </a:p>
           <a:p>
             <a:pPr lvl="2"/>
             <a:r>
-              <a:rPr lang="en-US" smtClean="0"/>
+              <a:rPr lang="en-US"/>
               <a:t>Third level</a:t>
             </a:r>
           </a:p>
           <a:p>
             <a:pPr lvl="3"/>
             <a:r>
-              <a:rPr lang="en-US" smtClean="0"/>
+              <a:rPr lang="en-US"/>
               <a:t>Fourth level</a:t>
             </a:r>
           </a:p>
           <a:p>
             <a:pPr lvl="4"/>
             <a:r>
-              <a:rPr lang="en-US" smtClean="0"/>
+              <a:rPr lang="en-US"/>
               <a:t>Fifth level</a:t>
             </a:r>
-            <a:endParaRPr lang="en-US"/>
           </a:p>
         </p:txBody>
       </p:sp>
@@ -647,7 +657,7 @@
           <a:p>
             <a:fld id="{5BCAD085-E8A6-8845-BD4E-CB4CCA059FC4}" type="datetimeFigureOut">
               <a:rPr lang="en-US" smtClean="0"/>
-              <a:t>1/27/13</a:t>
+              <a:t>9/11/26</a:t>
             </a:fld>
             <a:endParaRPr lang="en-US"/>
           </a:p>
@@ -741,10 +751,9 @@
           <a:lstStyle/>
           <a:p>
             <a:r>
-              <a:rPr lang="en-US" smtClean="0"/>
+              <a:rPr lang="en-US"/>
               <a:t>Click to edit Master title style</a:t>
             </a:r>
-            <a:endParaRPr lang="en-US"/>
           </a:p>
         </p:txBody>
       </p:sp>
@@ -765,38 +774,37 @@
           <a:p>
             <a:pPr lvl="0"/>
             <a:r>
-              <a:rPr lang="en-US" smtClean="0"/>
+              <a:rPr lang="en-US"/>
               <a:t>Click to edit Master text styles</a:t>
             </a:r>
           </a:p>
           <a:p>
             <a:pPr lvl="1"/>
             <a:r>
-              <a:rPr lang="en-US" smtClean="0"/>
+              <a:rPr lang="en-US"/>
               <a:t>Second level</a:t>
             </a:r>
           </a:p>
           <a:p>
             <a:pPr lvl="2"/>
             <a:r>
-              <a:rPr lang="en-US" smtClean="0"/>
+              <a:rPr lang="en-US"/>
               <a:t>Third level</a:t>
             </a:r>
           </a:p>
           <a:p>
             <a:pPr lvl="3"/>
             <a:r>
-              <a:rPr lang="en-US" smtClean="0"/>
+              <a:rPr lang="en-US"/>
               <a:t>Fourth level</a:t>
             </a:r>
           </a:p>
           <a:p>
             <a:pPr lvl="4"/>
             <a:r>
-              <a:rPr lang="en-US" smtClean="0"/>
+              <a:rPr lang="en-US"/>
               <a:t>Fifth level</a:t>
             </a:r>
-            <a:endParaRPr lang="en-US"/>
           </a:p>
         </p:txBody>
       </p:sp>
@@ -817,7 +825,7 @@
           <a:p>
             <a:fld id="{5BCAD085-E8A6-8845-BD4E-CB4CCA059FC4}" type="datetimeFigureOut">
               <a:rPr lang="en-US" smtClean="0"/>
-              <a:t>1/27/13</a:t>
+              <a:t>9/11/26</a:t>
             </a:fld>
             <a:endParaRPr lang="en-US"/>
           </a:p>
@@ -920,10 +928,9 @@
           </a:lstStyle>
           <a:p>
             <a:r>
-              <a:rPr lang="en-US" smtClean="0"/>
+              <a:rPr lang="en-US"/>
               <a:t>Click to edit Master title style</a:t>
             </a:r>
-            <a:endParaRPr lang="en-US"/>
           </a:p>
         </p:txBody>
       </p:sp>
@@ -1040,7 +1047,7 @@
           <a:p>
             <a:pPr lvl="0"/>
             <a:r>
-              <a:rPr lang="en-US" smtClean="0"/>
+              <a:rPr lang="en-US"/>
               <a:t>Click to edit Master text styles</a:t>
             </a:r>
           </a:p>
@@ -1063,7 +1070,7 @@
           <a:p>
             <a:fld id="{5BCAD085-E8A6-8845-BD4E-CB4CCA059FC4}" type="datetimeFigureOut">
               <a:rPr lang="en-US" smtClean="0"/>
-              <a:t>1/27/13</a:t>
+              <a:t>9/11/26</a:t>
             </a:fld>
             <a:endParaRPr lang="en-US"/>
           </a:p>
@@ -1157,10 +1164,9 @@
           <a:lstStyle/>
           <a:p>
             <a:r>
-              <a:rPr lang="en-US" smtClean="0"/>
+              <a:rPr lang="en-US"/>
               <a:t>Click to edit Master title style</a:t>
             </a:r>
-            <a:endParaRPr lang="en-US"/>
           </a:p>
         </p:txBody>
       </p:sp>
@@ -1214,38 +1220,37 @@
           <a:p>
             <a:pPr lvl="0"/>
             <a:r>
-              <a:rPr lang="en-US" smtClean="0"/>
+              <a:rPr lang="en-US"/>
               <a:t>Click to edit Master text styles</a:t>
             </a:r>
           </a:p>
           <a:p>
             <a:pPr lvl="1"/>
             <a:r>
-              <a:rPr lang="en-US" smtClean="0"/>
+              <a:rPr lang="en-US"/>
               <a:t>Second level</a:t>
             </a:r>
           </a:p>
           <a:p>
             <a:pPr lvl="2"/>
             <a:r>
-              <a:rPr lang="en-US" smtClean="0"/>
+              <a:rPr lang="en-US"/>
               <a:t>Third level</a:t>
             </a:r>
           </a:p>
           <a:p>
             <a:pPr lvl="3"/>
             <a:r>
-              <a:rPr lang="en-US" smtClean="0"/>
+              <a:rPr lang="en-US"/>
               <a:t>Fourth level</a:t>
             </a:r>
           </a:p>
           <a:p>
             <a:pPr lvl="4"/>
             <a:r>
-              <a:rPr lang="en-US" smtClean="0"/>
+              <a:rPr lang="en-US"/>
               <a:t>Fifth level</a:t>
             </a:r>
-            <a:endParaRPr lang="en-US"/>
           </a:p>
         </p:txBody>
       </p:sp>
@@ -1299,38 +1304,37 @@
           <a:p>
             <a:pPr lvl="0"/>
             <a:r>
-              <a:rPr lang="en-US" smtClean="0"/>
+              <a:rPr lang="en-US"/>
               <a:t>Click to edit Master text styles</a:t>
             </a:r>
           </a:p>
           <a:p>
             <a:pPr lvl="1"/>
             <a:r>
-              <a:rPr lang="en-US" smtClean="0"/>
+              <a:rPr lang="en-US"/>
               <a:t>Second level</a:t>
             </a:r>
           </a:p>
           <a:p>
             <a:pPr lvl="2"/>
             <a:r>
-              <a:rPr lang="en-US" smtClean="0"/>
+              <a:rPr lang="en-US"/>
               <a:t>Third level</a:t>
             </a:r>
           </a:p>
           <a:p>
             <a:pPr lvl="3"/>
             <a:r>
-              <a:rPr lang="en-US" smtClean="0"/>
+              <a:rPr lang="en-US"/>
               <a:t>Fourth level</a:t>
             </a:r>
           </a:p>
           <a:p>
             <a:pPr lvl="4"/>
             <a:r>
-              <a:rPr lang="en-US" smtClean="0"/>
+              <a:rPr lang="en-US"/>
               <a:t>Fifth level</a:t>
             </a:r>
-            <a:endParaRPr lang="en-US"/>
           </a:p>
         </p:txBody>
       </p:sp>
@@ -1351,7 +1355,7 @@
           <a:p>
             <a:fld id="{5BCAD085-E8A6-8845-BD4E-CB4CCA059FC4}" type="datetimeFigureOut">
               <a:rPr lang="en-US" smtClean="0"/>
-              <a:t>1/27/13</a:t>
+              <a:t>9/11/26</a:t>
             </a:fld>
             <a:endParaRPr lang="en-US"/>
           </a:p>
@@ -1449,10 +1453,9 @@
           </a:lstStyle>
           <a:p>
             <a:r>
-              <a:rPr lang="en-US" smtClean="0"/>
+              <a:rPr lang="en-US"/>
               <a:t>Click to edit Master title style</a:t>
             </a:r>
-            <a:endParaRPr lang="en-US"/>
           </a:p>
         </p:txBody>
       </p:sp>
@@ -1515,7 +1518,7 @@
           <a:p>
             <a:pPr lvl="0"/>
             <a:r>
-              <a:rPr lang="en-US" smtClean="0"/>
+              <a:rPr lang="en-US"/>
               <a:t>Click to edit Master text styles</a:t>
             </a:r>
           </a:p>
@@ -1571,38 +1574,37 @@
           <a:p>
             <a:pPr lvl="0"/>
             <a:r>
-              <a:rPr lang="en-US" smtClean="0"/>
+              <a:rPr lang="en-US"/>
               <a:t>Click to edit Master text styles</a:t>
             </a:r>
           </a:p>
           <a:p>
             <a:pPr lvl="1"/>
             <a:r>
-              <a:rPr lang="en-US" smtClean="0"/>
+              <a:rPr lang="en-US"/>
               <a:t>Second level</a:t>
             </a:r>
           </a:p>
           <a:p>
             <a:pPr lvl="2"/>
             <a:r>
-              <a:rPr lang="en-US" smtClean="0"/>
+              <a:rPr lang="en-US"/>
               <a:t>Third level</a:t>
             </a:r>
           </a:p>
           <a:p>
             <a:pPr lvl="3"/>
             <a:r>
-              <a:rPr lang="en-US" smtClean="0"/>
+              <a:rPr lang="en-US"/>
               <a:t>Fourth level</a:t>
             </a:r>
           </a:p>
           <a:p>
             <a:pPr lvl="4"/>
             <a:r>
-              <a:rPr lang="en-US" smtClean="0"/>
+              <a:rPr lang="en-US"/>
               <a:t>Fifth level</a:t>
             </a:r>
-            <a:endParaRPr lang="en-US"/>
           </a:p>
         </p:txBody>
       </p:sp>
@@ -1665,7 +1667,7 @@
           <a:p>
             <a:pPr lvl="0"/>
             <a:r>
-              <a:rPr lang="en-US" smtClean="0"/>
+              <a:rPr lang="en-US"/>
               <a:t>Click to edit Master text styles</a:t>
             </a:r>
           </a:p>
@@ -1721,38 +1723,37 @@
           <a:p>
             <a:pPr lvl="0"/>
             <a:r>
-              <a:rPr lang="en-US" smtClean="0"/>
+              <a:rPr lang="en-US"/>
               <a:t>Click to edit Master text styles</a:t>
             </a:r>
           </a:p>
           <a:p>
             <a:pPr lvl="1"/>
             <a:r>
-              <a:rPr lang="en-US" smtClean="0"/>
+              <a:rPr lang="en-US"/>
               <a:t>Second level</a:t>
             </a:r>
           </a:p>
           <a:p>
             <a:pPr lvl="2"/>
             <a:r>
-              <a:rPr lang="en-US" smtClean="0"/>
+              <a:rPr lang="en-US"/>
               <a:t>Third level</a:t>
             </a:r>
           </a:p>
           <a:p>
             <a:pPr lvl="3"/>
             <a:r>
-              <a:rPr lang="en-US" smtClean="0"/>
+              <a:rPr lang="en-US"/>
               <a:t>Fourth level</a:t>
             </a:r>
           </a:p>
           <a:p>
             <a:pPr lvl="4"/>
             <a:r>
-              <a:rPr lang="en-US" smtClean="0"/>
+              <a:rPr lang="en-US"/>
               <a:t>Fifth level</a:t>
             </a:r>
-            <a:endParaRPr lang="en-US"/>
           </a:p>
         </p:txBody>
       </p:sp>
@@ -1773,7 +1774,7 @@
           <a:p>
             <a:fld id="{5BCAD085-E8A6-8845-BD4E-CB4CCA059FC4}" type="datetimeFigureOut">
               <a:rPr lang="en-US" smtClean="0"/>
-              <a:t>1/27/13</a:t>
+              <a:t>9/11/26</a:t>
             </a:fld>
             <a:endParaRPr lang="en-US"/>
           </a:p>
@@ -1867,10 +1868,9 @@
           <a:lstStyle/>
           <a:p>
             <a:r>
-              <a:rPr lang="en-US" smtClean="0"/>
+              <a:rPr lang="en-US"/>
               <a:t>Click to edit Master title style</a:t>
             </a:r>
-            <a:endParaRPr lang="en-US"/>
           </a:p>
         </p:txBody>
       </p:sp>
@@ -1891,7 +1891,7 @@
           <a:p>
             <a:fld id="{5BCAD085-E8A6-8845-BD4E-CB4CCA059FC4}" type="datetimeFigureOut">
               <a:rPr lang="en-US" smtClean="0"/>
-              <a:t>1/27/13</a:t>
+              <a:t>9/11/26</a:t>
             </a:fld>
             <a:endParaRPr lang="en-US"/>
           </a:p>
@@ -1986,7 +1986,7 @@
           <a:p>
             <a:fld id="{5BCAD085-E8A6-8845-BD4E-CB4CCA059FC4}" type="datetimeFigureOut">
               <a:rPr lang="en-US" smtClean="0"/>
-              <a:t>1/27/13</a:t>
+              <a:t>9/11/26</a:t>
             </a:fld>
             <a:endParaRPr lang="en-US"/>
           </a:p>
@@ -2089,10 +2089,9 @@
           </a:lstStyle>
           <a:p>
             <a:r>
-              <a:rPr lang="en-US" smtClean="0"/>
+              <a:rPr lang="en-US"/>
               <a:t>Click to edit Master title style</a:t>
             </a:r>
-            <a:endParaRPr lang="en-US"/>
           </a:p>
         </p:txBody>
       </p:sp>
@@ -2146,38 +2145,37 @@
           <a:p>
             <a:pPr lvl="0"/>
             <a:r>
-              <a:rPr lang="en-US" smtClean="0"/>
+              <a:rPr lang="en-US"/>
               <a:t>Click to edit Master text styles</a:t>
             </a:r>
           </a:p>
           <a:p>
             <a:pPr lvl="1"/>
             <a:r>
-              <a:rPr lang="en-US" smtClean="0"/>
+              <a:rPr lang="en-US"/>
               <a:t>Second level</a:t>
             </a:r>
           </a:p>
           <a:p>
             <a:pPr lvl="2"/>
             <a:r>
-              <a:rPr lang="en-US" smtClean="0"/>
+              <a:rPr lang="en-US"/>
               <a:t>Third level</a:t>
             </a:r>
           </a:p>
           <a:p>
             <a:pPr lvl="3"/>
             <a:r>
-              <a:rPr lang="en-US" smtClean="0"/>
+              <a:rPr lang="en-US"/>
               <a:t>Fourth level</a:t>
             </a:r>
           </a:p>
           <a:p>
             <a:pPr lvl="4"/>
             <a:r>
-              <a:rPr lang="en-US" smtClean="0"/>
+              <a:rPr lang="en-US"/>
               <a:t>Fifth level</a:t>
             </a:r>
-            <a:endParaRPr lang="en-US"/>
           </a:p>
         </p:txBody>
       </p:sp>
@@ -2240,7 +2238,7 @@
           <a:p>
             <a:pPr lvl="0"/>
             <a:r>
-              <a:rPr lang="en-US" smtClean="0"/>
+              <a:rPr lang="en-US"/>
               <a:t>Click to edit Master text styles</a:t>
             </a:r>
           </a:p>
@@ -2263,7 +2261,7 @@
           <a:p>
             <a:fld id="{5BCAD085-E8A6-8845-BD4E-CB4CCA059FC4}" type="datetimeFigureOut">
               <a:rPr lang="en-US" smtClean="0"/>
-              <a:t>1/27/13</a:t>
+              <a:t>9/11/26</a:t>
             </a:fld>
             <a:endParaRPr lang="en-US"/>
           </a:p>
@@ -2366,10 +2364,9 @@
           </a:lstStyle>
           <a:p>
             <a:r>
-              <a:rPr lang="en-US" smtClean="0"/>
+              <a:rPr lang="en-US"/>
               <a:t>Click to edit Master title style</a:t>
             </a:r>
-            <a:endParaRPr lang="en-US"/>
           </a:p>
         </p:txBody>
       </p:sp>
@@ -2493,7 +2490,7 @@
           <a:p>
             <a:pPr lvl="0"/>
             <a:r>
-              <a:rPr lang="en-US" smtClean="0"/>
+              <a:rPr lang="en-US"/>
               <a:t>Click to edit Master text styles</a:t>
             </a:r>
           </a:p>
@@ -2516,7 +2513,7 @@
           <a:p>
             <a:fld id="{5BCAD085-E8A6-8845-BD4E-CB4CCA059FC4}" type="datetimeFigureOut">
               <a:rPr lang="en-US" smtClean="0"/>
-              <a:t>1/27/13</a:t>
+              <a:t>9/11/26</a:t>
             </a:fld>
             <a:endParaRPr lang="en-US"/>
           </a:p>
@@ -2625,10 +2622,9 @@
           <a:lstStyle/>
           <a:p>
             <a:r>
-              <a:rPr lang="en-US" smtClean="0"/>
+              <a:rPr lang="en-US"/>
               <a:t>Click to edit Master title style</a:t>
             </a:r>
-            <a:endParaRPr lang="en-US"/>
           </a:p>
         </p:txBody>
       </p:sp>
@@ -2659,38 +2655,37 @@
           <a:p>
             <a:pPr lvl="0"/>
             <a:r>
-              <a:rPr lang="en-US" smtClean="0"/>
+              <a:rPr lang="en-US"/>
               <a:t>Click to edit Master text styles</a:t>
             </a:r>
           </a:p>
           <a:p>
             <a:pPr lvl="1"/>
             <a:r>
-              <a:rPr lang="en-US" smtClean="0"/>
+              <a:rPr lang="en-US"/>
               <a:t>Second level</a:t>
             </a:r>
           </a:p>
           <a:p>
             <a:pPr lvl="2"/>
             <a:r>
-              <a:rPr lang="en-US" smtClean="0"/>
+              <a:rPr lang="en-US"/>
               <a:t>Third level</a:t>
             </a:r>
           </a:p>
           <a:p>
             <a:pPr lvl="3"/>
             <a:r>
-              <a:rPr lang="en-US" smtClean="0"/>
+              <a:rPr lang="en-US"/>
               <a:t>Fourth level</a:t>
             </a:r>
           </a:p>
           <a:p>
             <a:pPr lvl="4"/>
             <a:r>
-              <a:rPr lang="en-US" smtClean="0"/>
+              <a:rPr lang="en-US"/>
               <a:t>Fifth level</a:t>
             </a:r>
-            <a:endParaRPr lang="en-US"/>
           </a:p>
         </p:txBody>
       </p:sp>
@@ -2729,7 +2724,7 @@
           <a:p>
             <a:fld id="{5BCAD085-E8A6-8845-BD4E-CB4CCA059FC4}" type="datetimeFigureOut">
               <a:rPr lang="en-US" smtClean="0"/>
-              <a:t>1/27/13</a:t>
+              <a:t>9/11/26</a:t>
             </a:fld>
             <a:endParaRPr lang="en-US"/>
           </a:p>
@@ -3088,7 +3083,7 @@
 </file>
 
 <file path=ppt/slides/slide1.xml><?xml version="1.0" encoding="utf-8"?>
-<p:sld xmlns:a="http://schemas.openxmlformats.org/drawingml/2006/main" xmlns:p="http://schemas.openxmlformats.org/presentationml/2006/main" xmlns:r="http://schemas.openxmlformats.org/officeDocument/2006/relationships">
+<p:sld xmlns:a="http://schemas.openxmlformats.org/drawingml/2006/main" xmlns:r="http://schemas.openxmlformats.org/officeDocument/2006/relationships" xmlns:p="http://schemas.openxmlformats.org/presentationml/2006/main">
   <p:cSld>
     <p:bg>
       <p:bgPr>
@@ -3104,7 +3099,14 @@
         <p:cNvGrpSpPr/>
         <p:nvPr/>
       </p:nvGrpSpPr>
-      <p:grpSpPr/>
+      <p:grpSpPr>
+        <a:xfrm>
+          <a:off x="0" y="0"/>
+          <a:ext cx="0" cy="0"/>
+          <a:chOff x="0" y="0"/>
+          <a:chExt cx="0" cy="0"/>
+        </a:xfrm>
+      </p:grpSpPr>
       <p:sp>
         <p:nvSpPr>
           <p:cNvPr id="2" name="Rectangle 1"/>
@@ -3146,6 +3148,7 @@
           <a:lstStyle/>
           <a:p>
             <a:pPr algn="ctr"/>
+            <a:endParaRPr/>
           </a:p>
         </p:txBody>
       </p:sp>
@@ -3166,7 +3169,7 @@
           <a:noFill/>
         </p:spPr>
         <p:txBody>
-          <a:bodyPr wrap="square" lIns="0" rIns="0" tIns="0" bIns="0" anchor="t">
+          <a:bodyPr wrap="square" lIns="0" tIns="0" rIns="0" bIns="0" anchor="t">
             <a:spAutoFit/>
           </a:bodyPr>
           <a:lstStyle/>
@@ -3201,7 +3204,7 @@
           <a:noFill/>
         </p:spPr>
         <p:txBody>
-          <a:bodyPr wrap="square" lIns="0" rIns="0" tIns="0" bIns="0" anchor="t">
+          <a:bodyPr wrap="square" lIns="0" tIns="0" rIns="0" bIns="0" anchor="t">
             <a:spAutoFit/>
           </a:bodyPr>
           <a:lstStyle/>
@@ -3240,7 +3243,7 @@
           <a:noFill/>
         </p:spPr>
         <p:txBody>
-          <a:bodyPr wrap="square" lIns="0" rIns="0" tIns="0" bIns="0" anchor="t">
+          <a:bodyPr wrap="square" lIns="0" tIns="0" rIns="0" bIns="0" anchor="t">
             <a:spAutoFit/>
           </a:bodyPr>
           <a:lstStyle/>
@@ -3279,7 +3282,7 @@
           <a:noFill/>
         </p:spPr>
         <p:txBody>
-          <a:bodyPr wrap="square" lIns="0" rIns="0" tIns="0" bIns="0" anchor="t">
+          <a:bodyPr wrap="square" lIns="0" tIns="0" rIns="0" bIns="0" anchor="t">
             <a:spAutoFit/>
           </a:bodyPr>
           <a:lstStyle/>
@@ -3342,6 +3345,7 @@
           <a:lstStyle/>
           <a:p>
             <a:pPr algn="ctr"/>
+            <a:endParaRPr/>
           </a:p>
         </p:txBody>
       </p:sp>
@@ -3362,7 +3366,7 @@
           <a:noFill/>
         </p:spPr>
         <p:txBody>
-          <a:bodyPr wrap="square" lIns="0" rIns="0" tIns="0" bIns="0" anchor="t">
+          <a:bodyPr wrap="square" lIns="0" tIns="0" rIns="0" bIns="0" anchor="t">
             <a:spAutoFit/>
           </a:bodyPr>
           <a:lstStyle/>
@@ -3397,7 +3401,7 @@
           <a:noFill/>
         </p:spPr>
         <p:txBody>
-          <a:bodyPr wrap="square" lIns="0" rIns="0" tIns="0" bIns="0" anchor="t">
+          <a:bodyPr wrap="square" lIns="0" tIns="0" rIns="0" bIns="0" anchor="t">
             <a:spAutoFit/>
           </a:bodyPr>
           <a:lstStyle/>
@@ -3424,7 +3428,7 @@
 </file>
 
 <file path=ppt/slides/slide10.xml><?xml version="1.0" encoding="utf-8"?>
-<p:sld xmlns:a="http://schemas.openxmlformats.org/drawingml/2006/main" xmlns:p="http://schemas.openxmlformats.org/presentationml/2006/main" xmlns:r="http://schemas.openxmlformats.org/officeDocument/2006/relationships">
+<p:sld xmlns:a="http://schemas.openxmlformats.org/drawingml/2006/main" xmlns:r="http://schemas.openxmlformats.org/officeDocument/2006/relationships" xmlns:p="http://schemas.openxmlformats.org/presentationml/2006/main">
   <p:cSld>
     <p:bg>
       <p:bgPr>
@@ -3440,7 +3444,14 @@
         <p:cNvGrpSpPr/>
         <p:nvPr/>
       </p:nvGrpSpPr>
-      <p:grpSpPr/>
+      <p:grpSpPr>
+        <a:xfrm>
+          <a:off x="0" y="0"/>
+          <a:ext cx="0" cy="0"/>
+          <a:chOff x="0" y="0"/>
+          <a:chExt cx="0" cy="0"/>
+        </a:xfrm>
+      </p:grpSpPr>
       <p:sp>
         <p:nvSpPr>
           <p:cNvPr id="2" name="TextBox 1"/>
@@ -3458,7 +3469,7 @@
           <a:noFill/>
         </p:spPr>
         <p:txBody>
-          <a:bodyPr wrap="square" lIns="0" rIns="0" tIns="0" bIns="0" anchor="t">
+          <a:bodyPr wrap="square" lIns="0" tIns="0" rIns="0" bIns="0" anchor="t">
             <a:spAutoFit/>
           </a:bodyPr>
           <a:lstStyle/>
@@ -3493,7 +3504,7 @@
           <a:noFill/>
         </p:spPr>
         <p:txBody>
-          <a:bodyPr wrap="square" lIns="0" rIns="0" tIns="0" bIns="0" anchor="t">
+          <a:bodyPr wrap="square" lIns="0" tIns="0" rIns="0" bIns="0" anchor="t">
             <a:spAutoFit/>
           </a:bodyPr>
           <a:lstStyle/>
@@ -3552,6 +3563,7 @@
           <a:lstStyle/>
           <a:p>
             <a:pPr algn="ctr"/>
+            <a:endParaRPr/>
           </a:p>
         </p:txBody>
       </p:sp>
@@ -3572,7 +3584,7 @@
           <a:noFill/>
         </p:spPr>
         <p:txBody>
-          <a:bodyPr wrap="square" lIns="0" rIns="0" tIns="0" bIns="0" anchor="t">
+          <a:bodyPr wrap="square" lIns="0" tIns="0" rIns="0" bIns="0" anchor="t">
             <a:spAutoFit/>
           </a:bodyPr>
           <a:lstStyle/>
@@ -3611,7 +3623,7 @@
           <a:noFill/>
         </p:spPr>
         <p:txBody>
-          <a:bodyPr wrap="square" lIns="0" rIns="0" tIns="0" bIns="0" anchor="t">
+          <a:bodyPr wrap="square" lIns="0" tIns="0" rIns="0" bIns="0" anchor="t">
             <a:spAutoFit/>
           </a:bodyPr>
           <a:lstStyle/>
@@ -3646,7 +3658,7 @@
           <a:noFill/>
         </p:spPr>
         <p:txBody>
-          <a:bodyPr wrap="square" lIns="0" rIns="0" tIns="0" bIns="0" anchor="t">
+          <a:bodyPr wrap="square" lIns="0" tIns="0" rIns="0" bIns="0" anchor="t">
             <a:spAutoFit/>
           </a:bodyPr>
           <a:lstStyle/>
@@ -3681,7 +3693,7 @@
           <a:noFill/>
         </p:spPr>
         <p:txBody>
-          <a:bodyPr wrap="square" lIns="0" rIns="0" tIns="0" bIns="0" anchor="t">
+          <a:bodyPr wrap="square" lIns="0" tIns="0" rIns="0" bIns="0" anchor="t">
             <a:spAutoFit/>
           </a:bodyPr>
           <a:lstStyle/>
@@ -3744,6 +3756,7 @@
           <a:lstStyle/>
           <a:p>
             <a:pPr algn="ctr"/>
+            <a:endParaRPr/>
           </a:p>
         </p:txBody>
       </p:sp>
@@ -3764,7 +3777,7 @@
           <a:noFill/>
         </p:spPr>
         <p:txBody>
-          <a:bodyPr wrap="square" lIns="0" rIns="0" tIns="0" bIns="0" anchor="t">
+          <a:bodyPr wrap="square" lIns="0" tIns="0" rIns="0" bIns="0" anchor="t">
             <a:spAutoFit/>
           </a:bodyPr>
           <a:lstStyle/>
@@ -3799,7 +3812,7 @@
           <a:noFill/>
         </p:spPr>
         <p:txBody>
-          <a:bodyPr wrap="square" lIns="0" rIns="0" tIns="0" bIns="0" anchor="t">
+          <a:bodyPr wrap="square" lIns="0" tIns="0" rIns="0" bIns="0" anchor="t">
             <a:spAutoFit/>
           </a:bodyPr>
           <a:lstStyle/>
@@ -3834,7 +3847,7 @@
           <a:noFill/>
         </p:spPr>
         <p:txBody>
-          <a:bodyPr wrap="square" lIns="0" rIns="0" tIns="0" bIns="0" anchor="t">
+          <a:bodyPr wrap="square" lIns="0" tIns="0" rIns="0" bIns="0" anchor="t">
             <a:spAutoFit/>
           </a:bodyPr>
           <a:lstStyle/>
@@ -3897,6 +3910,7 @@
           <a:lstStyle/>
           <a:p>
             <a:pPr algn="ctr"/>
+            <a:endParaRPr/>
           </a:p>
         </p:txBody>
       </p:sp>
@@ -3917,7 +3931,7 @@
           <a:noFill/>
         </p:spPr>
         <p:txBody>
-          <a:bodyPr wrap="square" lIns="0" rIns="0" tIns="0" bIns="0" anchor="t">
+          <a:bodyPr wrap="square" lIns="0" tIns="0" rIns="0" bIns="0" anchor="t">
             <a:spAutoFit/>
           </a:bodyPr>
           <a:lstStyle/>
@@ -3952,7 +3966,7 @@
           <a:noFill/>
         </p:spPr>
         <p:txBody>
-          <a:bodyPr wrap="square" lIns="0" rIns="0" tIns="0" bIns="0" anchor="t">
+          <a:bodyPr wrap="square" lIns="0" tIns="0" rIns="0" bIns="0" anchor="t">
             <a:spAutoFit/>
           </a:bodyPr>
           <a:lstStyle/>
@@ -3987,7 +4001,7 @@
           <a:noFill/>
         </p:spPr>
         <p:txBody>
-          <a:bodyPr wrap="square" lIns="0" rIns="0" tIns="0" bIns="0" anchor="t">
+          <a:bodyPr wrap="square" lIns="0" tIns="0" rIns="0" bIns="0" anchor="t">
             <a:spAutoFit/>
           </a:bodyPr>
           <a:lstStyle/>
@@ -4017,8 +4031,8 @@
         </p:nvSpPr>
         <p:spPr>
           <a:xfrm>
-            <a:off x="685800" y="4610100"/>
-            <a:ext cx="10820400" cy="1219200"/>
+            <a:off x="685800" y="4610099"/>
+            <a:ext cx="10820400" cy="1457325"/>
           </a:xfrm>
           <a:prstGeom prst="rect">
             <a:avLst/>
@@ -4050,6 +4064,7 @@
           <a:lstStyle/>
           <a:p>
             <a:pPr algn="ctr"/>
+            <a:endParaRPr/>
           </a:p>
         </p:txBody>
       </p:sp>
@@ -4094,6 +4109,7 @@
           <a:lstStyle/>
           <a:p>
             <a:pPr algn="ctr"/>
+            <a:endParaRPr/>
           </a:p>
         </p:txBody>
       </p:sp>
@@ -4114,7 +4130,7 @@
           <a:noFill/>
         </p:spPr>
         <p:txBody>
-          <a:bodyPr wrap="square" lIns="0" rIns="0" tIns="0" bIns="0" anchor="t">
+          <a:bodyPr wrap="square" lIns="0" tIns="0" rIns="0" bIns="0" anchor="t">
             <a:spAutoFit/>
           </a:bodyPr>
           <a:lstStyle/>
@@ -4149,7 +4165,7 @@
           <a:noFill/>
         </p:spPr>
         <p:txBody>
-          <a:bodyPr wrap="square" lIns="0" rIns="0" tIns="0" bIns="0" anchor="t">
+          <a:bodyPr wrap="square" lIns="0" tIns="0" rIns="0" bIns="0" anchor="t">
             <a:spAutoFit/>
           </a:bodyPr>
           <a:lstStyle/>
@@ -4212,6 +4228,7 @@
           <a:lstStyle/>
           <a:p>
             <a:pPr algn="ctr"/>
+            <a:endParaRPr/>
           </a:p>
         </p:txBody>
       </p:sp>
@@ -4232,7 +4249,7 @@
           <a:noFill/>
         </p:spPr>
         <p:txBody>
-          <a:bodyPr wrap="square" lIns="0" rIns="0" tIns="0" bIns="0" anchor="t">
+          <a:bodyPr wrap="square" lIns="0" tIns="0" rIns="0" bIns="0" anchor="t">
             <a:spAutoFit/>
           </a:bodyPr>
           <a:lstStyle/>
@@ -4259,7 +4276,7 @@
 </file>
 
 <file path=ppt/slides/slide2.xml><?xml version="1.0" encoding="utf-8"?>
-<p:sld xmlns:a="http://schemas.openxmlformats.org/drawingml/2006/main" xmlns:p="http://schemas.openxmlformats.org/presentationml/2006/main" xmlns:r="http://schemas.openxmlformats.org/officeDocument/2006/relationships">
+<p:sld xmlns:a="http://schemas.openxmlformats.org/drawingml/2006/main" xmlns:r="http://schemas.openxmlformats.org/officeDocument/2006/relationships" xmlns:p="http://schemas.openxmlformats.org/presentationml/2006/main">
   <p:cSld>
     <p:bg>
       <p:bgPr>
@@ -4275,7 +4292,14 @@
         <p:cNvGrpSpPr/>
         <p:nvPr/>
       </p:nvGrpSpPr>
-      <p:grpSpPr/>
+      <p:grpSpPr>
+        <a:xfrm>
+          <a:off x="0" y="0"/>
+          <a:ext cx="0" cy="0"/>
+          <a:chOff x="0" y="0"/>
+          <a:chExt cx="0" cy="0"/>
+        </a:xfrm>
+      </p:grpSpPr>
       <p:sp>
         <p:nvSpPr>
           <p:cNvPr id="2" name="TextBox 1"/>
@@ -4293,7 +4317,7 @@
           <a:noFill/>
         </p:spPr>
         <p:txBody>
-          <a:bodyPr wrap="square" lIns="0" rIns="0" tIns="0" bIns="0" anchor="t">
+          <a:bodyPr wrap="square" lIns="0" tIns="0" rIns="0" bIns="0" anchor="t">
             <a:spAutoFit/>
           </a:bodyPr>
           <a:lstStyle/>
@@ -4328,7 +4352,7 @@
           <a:noFill/>
         </p:spPr>
         <p:txBody>
-          <a:bodyPr wrap="square" lIns="0" rIns="0" tIns="0" bIns="0" anchor="t">
+          <a:bodyPr wrap="square" lIns="0" tIns="0" rIns="0" bIns="0" anchor="t">
             <a:spAutoFit/>
           </a:bodyPr>
           <a:lstStyle/>
@@ -4387,6 +4411,7 @@
           <a:lstStyle/>
           <a:p>
             <a:pPr algn="ctr"/>
+            <a:endParaRPr/>
           </a:p>
         </p:txBody>
       </p:sp>
@@ -4407,7 +4432,7 @@
           <a:noFill/>
         </p:spPr>
         <p:txBody>
-          <a:bodyPr wrap="square" lIns="0" rIns="0" tIns="0" bIns="0" anchor="t">
+          <a:bodyPr wrap="square" lIns="0" tIns="0" rIns="0" bIns="0" anchor="t">
             <a:spAutoFit/>
           </a:bodyPr>
           <a:lstStyle/>
@@ -4446,7 +4471,7 @@
           <a:noFill/>
         </p:spPr>
         <p:txBody>
-          <a:bodyPr wrap="square" lIns="0" rIns="0" tIns="0" bIns="0" anchor="t">
+          <a:bodyPr wrap="square" lIns="0" tIns="0" rIns="0" bIns="0" anchor="t">
             <a:spAutoFit/>
           </a:bodyPr>
           <a:lstStyle/>
@@ -4485,7 +4510,7 @@
           <a:noFill/>
         </p:spPr>
         <p:txBody>
-          <a:bodyPr wrap="square" lIns="0" rIns="0" tIns="0" bIns="0" anchor="t">
+          <a:bodyPr wrap="square" lIns="0" tIns="0" rIns="0" bIns="0" anchor="t">
             <a:spAutoFit/>
           </a:bodyPr>
           <a:lstStyle/>
@@ -4550,6 +4575,7 @@
           <a:lstStyle/>
           <a:p>
             <a:pPr algn="ctr"/>
+            <a:endParaRPr/>
           </a:p>
         </p:txBody>
       </p:sp>
@@ -4570,7 +4596,7 @@
           <a:noFill/>
         </p:spPr>
         <p:txBody>
-          <a:bodyPr wrap="square" lIns="0" rIns="0" tIns="0" bIns="0" anchor="t">
+          <a:bodyPr wrap="square" lIns="0" tIns="0" rIns="0" bIns="0" anchor="t">
             <a:spAutoFit/>
           </a:bodyPr>
           <a:lstStyle/>
@@ -4629,6 +4655,7 @@
           <a:lstStyle/>
           <a:p>
             <a:pPr algn="ctr"/>
+            <a:endParaRPr/>
           </a:p>
         </p:txBody>
       </p:sp>
@@ -4649,7 +4676,7 @@
           <a:noFill/>
         </p:spPr>
         <p:txBody>
-          <a:bodyPr wrap="square" lIns="0" rIns="0" tIns="0" bIns="0" anchor="t">
+          <a:bodyPr wrap="square" lIns="0" tIns="0" rIns="0" bIns="0" anchor="t">
             <a:spAutoFit/>
           </a:bodyPr>
           <a:lstStyle/>
@@ -4712,6 +4739,7 @@
           <a:lstStyle/>
           <a:p>
             <a:pPr algn="ctr"/>
+            <a:endParaRPr/>
           </a:p>
         </p:txBody>
       </p:sp>
@@ -4756,6 +4784,7 @@
           <a:lstStyle/>
           <a:p>
             <a:pPr algn="ctr"/>
+            <a:endParaRPr/>
           </a:p>
         </p:txBody>
       </p:sp>
@@ -4776,7 +4805,7 @@
           <a:noFill/>
         </p:spPr>
         <p:txBody>
-          <a:bodyPr wrap="square" lIns="0" rIns="0" tIns="0" bIns="0" anchor="t">
+          <a:bodyPr wrap="square" lIns="0" tIns="0" rIns="0" bIns="0" anchor="t">
             <a:spAutoFit/>
           </a:bodyPr>
           <a:lstStyle/>
@@ -4811,7 +4840,7 @@
           <a:noFill/>
         </p:spPr>
         <p:txBody>
-          <a:bodyPr wrap="square" lIns="0" rIns="0" tIns="0" bIns="0" anchor="t">
+          <a:bodyPr wrap="square" lIns="0" tIns="0" rIns="0" bIns="0" anchor="t">
             <a:spAutoFit/>
           </a:bodyPr>
           <a:lstStyle/>
@@ -4874,6 +4903,7 @@
           <a:lstStyle/>
           <a:p>
             <a:pPr algn="ctr"/>
+            <a:endParaRPr/>
           </a:p>
         </p:txBody>
       </p:sp>
@@ -4894,7 +4924,7 @@
           <a:noFill/>
         </p:spPr>
         <p:txBody>
-          <a:bodyPr wrap="square" lIns="0" rIns="0" tIns="0" bIns="0" anchor="t">
+          <a:bodyPr wrap="square" lIns="0" tIns="0" rIns="0" bIns="0" anchor="t">
             <a:spAutoFit/>
           </a:bodyPr>
           <a:lstStyle/>
@@ -4921,7 +4951,7 @@
 </file>
 
 <file path=ppt/slides/slide3.xml><?xml version="1.0" encoding="utf-8"?>
-<p:sld xmlns:a="http://schemas.openxmlformats.org/drawingml/2006/main" xmlns:p="http://schemas.openxmlformats.org/presentationml/2006/main" xmlns:r="http://schemas.openxmlformats.org/officeDocument/2006/relationships">
+<p:sld xmlns:a="http://schemas.openxmlformats.org/drawingml/2006/main" xmlns:r="http://schemas.openxmlformats.org/officeDocument/2006/relationships" xmlns:p="http://schemas.openxmlformats.org/presentationml/2006/main">
   <p:cSld>
     <p:bg>
       <p:bgPr>
@@ -4937,7 +4967,14 @@
         <p:cNvGrpSpPr/>
         <p:nvPr/>
       </p:nvGrpSpPr>
-      <p:grpSpPr/>
+      <p:grpSpPr>
+        <a:xfrm>
+          <a:off x="0" y="0"/>
+          <a:ext cx="0" cy="0"/>
+          <a:chOff x="0" y="0"/>
+          <a:chExt cx="0" cy="0"/>
+        </a:xfrm>
+      </p:grpSpPr>
       <p:sp>
         <p:nvSpPr>
           <p:cNvPr id="2" name="TextBox 1"/>
@@ -4955,7 +4992,7 @@
           <a:noFill/>
         </p:spPr>
         <p:txBody>
-          <a:bodyPr wrap="square" lIns="0" rIns="0" tIns="0" bIns="0" anchor="t">
+          <a:bodyPr wrap="square" lIns="0" tIns="0" rIns="0" bIns="0" anchor="t">
             <a:spAutoFit/>
           </a:bodyPr>
           <a:lstStyle/>
@@ -4990,7 +5027,7 @@
           <a:noFill/>
         </p:spPr>
         <p:txBody>
-          <a:bodyPr wrap="square" lIns="0" rIns="0" tIns="0" bIns="0" anchor="t">
+          <a:bodyPr wrap="square" lIns="0" tIns="0" rIns="0" bIns="0" anchor="t">
             <a:spAutoFit/>
           </a:bodyPr>
           <a:lstStyle/>
@@ -5049,6 +5086,7 @@
           <a:lstStyle/>
           <a:p>
             <a:pPr algn="ctr"/>
+            <a:endParaRPr/>
           </a:p>
         </p:txBody>
       </p:sp>
@@ -5069,7 +5107,7 @@
           <a:noFill/>
         </p:spPr>
         <p:txBody>
-          <a:bodyPr wrap="square" lIns="0" rIns="0" tIns="0" bIns="0" anchor="t">
+          <a:bodyPr wrap="square" lIns="0" tIns="0" rIns="0" bIns="0" anchor="t">
             <a:spAutoFit/>
           </a:bodyPr>
           <a:lstStyle/>
@@ -5134,6 +5172,7 @@
           <a:lstStyle/>
           <a:p>
             <a:pPr algn="ctr"/>
+            <a:endParaRPr/>
           </a:p>
         </p:txBody>
       </p:sp>
@@ -5178,6 +5217,7 @@
           <a:lstStyle/>
           <a:p>
             <a:pPr algn="ctr"/>
+            <a:endParaRPr/>
           </a:p>
         </p:txBody>
       </p:sp>
@@ -5198,7 +5238,7 @@
           <a:noFill/>
         </p:spPr>
         <p:txBody>
-          <a:bodyPr wrap="square" lIns="0" rIns="0" tIns="0" bIns="0" anchor="t">
+          <a:bodyPr wrap="square" lIns="0" tIns="0" rIns="0" bIns="0" anchor="t">
             <a:spAutoFit/>
           </a:bodyPr>
           <a:lstStyle/>
@@ -5233,7 +5273,7 @@
           <a:noFill/>
         </p:spPr>
         <p:txBody>
-          <a:bodyPr wrap="square" lIns="0" rIns="0" tIns="0" bIns="0" anchor="t">
+          <a:bodyPr wrap="square" lIns="0" tIns="0" rIns="0" bIns="0" anchor="t">
             <a:spAutoFit/>
           </a:bodyPr>
           <a:lstStyle/>
@@ -5272,7 +5312,7 @@
           <a:noFill/>
         </p:spPr>
         <p:txBody>
-          <a:bodyPr wrap="square" lIns="0" rIns="0" tIns="0" bIns="0" anchor="t">
+          <a:bodyPr wrap="square" lIns="0" tIns="0" rIns="0" bIns="0" anchor="t">
             <a:spAutoFit/>
           </a:bodyPr>
           <a:lstStyle/>
@@ -5333,6 +5373,7 @@
           <a:lstStyle/>
           <a:p>
             <a:pPr algn="ctr"/>
+            <a:endParaRPr/>
           </a:p>
         </p:txBody>
       </p:sp>
@@ -5377,6 +5418,7 @@
           <a:lstStyle/>
           <a:p>
             <a:pPr algn="ctr"/>
+            <a:endParaRPr/>
           </a:p>
         </p:txBody>
       </p:sp>
@@ -5397,7 +5439,7 @@
           <a:noFill/>
         </p:spPr>
         <p:txBody>
-          <a:bodyPr wrap="square" lIns="0" rIns="0" tIns="0" bIns="0" anchor="t">
+          <a:bodyPr wrap="square" lIns="0" tIns="0" rIns="0" bIns="0" anchor="t">
             <a:spAutoFit/>
           </a:bodyPr>
           <a:lstStyle/>
@@ -5432,7 +5474,7 @@
           <a:noFill/>
         </p:spPr>
         <p:txBody>
-          <a:bodyPr wrap="square" lIns="0" rIns="0" tIns="0" bIns="0" anchor="t">
+          <a:bodyPr wrap="square" lIns="0" tIns="0" rIns="0" bIns="0" anchor="t">
             <a:spAutoFit/>
           </a:bodyPr>
           <a:lstStyle/>
@@ -5471,7 +5513,7 @@
           <a:noFill/>
         </p:spPr>
         <p:txBody>
-          <a:bodyPr wrap="square" lIns="0" rIns="0" tIns="0" bIns="0" anchor="t">
+          <a:bodyPr wrap="square" lIns="0" tIns="0" rIns="0" bIns="0" anchor="t">
             <a:spAutoFit/>
           </a:bodyPr>
           <a:lstStyle/>
@@ -5532,6 +5574,7 @@
           <a:lstStyle/>
           <a:p>
             <a:pPr algn="ctr"/>
+            <a:endParaRPr/>
           </a:p>
         </p:txBody>
       </p:sp>
@@ -5576,6 +5619,7 @@
           <a:lstStyle/>
           <a:p>
             <a:pPr algn="ctr"/>
+            <a:endParaRPr/>
           </a:p>
         </p:txBody>
       </p:sp>
@@ -5596,7 +5640,7 @@
           <a:noFill/>
         </p:spPr>
         <p:txBody>
-          <a:bodyPr wrap="square" lIns="0" rIns="0" tIns="0" bIns="0" anchor="t">
+          <a:bodyPr wrap="square" lIns="0" tIns="0" rIns="0" bIns="0" anchor="t">
             <a:spAutoFit/>
           </a:bodyPr>
           <a:lstStyle/>
@@ -5631,7 +5675,7 @@
           <a:noFill/>
         </p:spPr>
         <p:txBody>
-          <a:bodyPr wrap="square" lIns="0" rIns="0" tIns="0" bIns="0" anchor="t">
+          <a:bodyPr wrap="square" lIns="0" tIns="0" rIns="0" bIns="0" anchor="t">
             <a:spAutoFit/>
           </a:bodyPr>
           <a:lstStyle/>
@@ -5670,7 +5714,7 @@
           <a:noFill/>
         </p:spPr>
         <p:txBody>
-          <a:bodyPr wrap="square" lIns="0" rIns="0" tIns="0" bIns="0" anchor="t">
+          <a:bodyPr wrap="square" lIns="0" tIns="0" rIns="0" bIns="0" anchor="t">
             <a:spAutoFit/>
           </a:bodyPr>
           <a:lstStyle/>
@@ -5705,7 +5749,7 @@
           <a:noFill/>
         </p:spPr>
         <p:txBody>
-          <a:bodyPr wrap="square" lIns="0" rIns="0" tIns="0" bIns="0" anchor="t">
+          <a:bodyPr wrap="square" lIns="0" tIns="0" rIns="0" bIns="0" anchor="t">
             <a:spAutoFit/>
           </a:bodyPr>
           <a:lstStyle/>
@@ -5766,6 +5810,7 @@
           <a:lstStyle/>
           <a:p>
             <a:pPr algn="ctr"/>
+            <a:endParaRPr/>
           </a:p>
         </p:txBody>
       </p:sp>
@@ -5810,6 +5855,7 @@
           <a:lstStyle/>
           <a:p>
             <a:pPr algn="ctr"/>
+            <a:endParaRPr/>
           </a:p>
         </p:txBody>
       </p:sp>
@@ -5830,7 +5876,7 @@
           <a:noFill/>
         </p:spPr>
         <p:txBody>
-          <a:bodyPr wrap="square" lIns="0" rIns="0" tIns="0" bIns="0" anchor="t">
+          <a:bodyPr wrap="square" lIns="0" tIns="0" rIns="0" bIns="0" anchor="t">
             <a:spAutoFit/>
           </a:bodyPr>
           <a:lstStyle/>
@@ -5865,7 +5911,7 @@
           <a:noFill/>
         </p:spPr>
         <p:txBody>
-          <a:bodyPr wrap="square" lIns="0" rIns="0" tIns="0" bIns="0" anchor="t">
+          <a:bodyPr wrap="square" lIns="0" tIns="0" rIns="0" bIns="0" anchor="t">
             <a:spAutoFit/>
           </a:bodyPr>
           <a:lstStyle/>
@@ -5904,7 +5950,7 @@
           <a:noFill/>
         </p:spPr>
         <p:txBody>
-          <a:bodyPr wrap="square" lIns="0" rIns="0" tIns="0" bIns="0" anchor="t">
+          <a:bodyPr wrap="square" lIns="0" tIns="0" rIns="0" bIns="0" anchor="t">
             <a:spAutoFit/>
           </a:bodyPr>
           <a:lstStyle/>
@@ -5965,6 +6011,7 @@
           <a:lstStyle/>
           <a:p>
             <a:pPr algn="ctr"/>
+            <a:endParaRPr/>
           </a:p>
         </p:txBody>
       </p:sp>
@@ -6009,6 +6056,7 @@
           <a:lstStyle/>
           <a:p>
             <a:pPr algn="ctr"/>
+            <a:endParaRPr/>
           </a:p>
         </p:txBody>
       </p:sp>
@@ -6029,7 +6077,7 @@
           <a:noFill/>
         </p:spPr>
         <p:txBody>
-          <a:bodyPr wrap="square" lIns="0" rIns="0" tIns="0" bIns="0" anchor="t">
+          <a:bodyPr wrap="square" lIns="0" tIns="0" rIns="0" bIns="0" anchor="t">
             <a:spAutoFit/>
           </a:bodyPr>
           <a:lstStyle/>
@@ -6064,7 +6112,7 @@
           <a:noFill/>
         </p:spPr>
         <p:txBody>
-          <a:bodyPr wrap="square" lIns="0" rIns="0" tIns="0" bIns="0" anchor="t">
+          <a:bodyPr wrap="square" lIns="0" tIns="0" rIns="0" bIns="0" anchor="t">
             <a:spAutoFit/>
           </a:bodyPr>
           <a:lstStyle/>
@@ -6127,6 +6175,7 @@
           <a:lstStyle/>
           <a:p>
             <a:pPr algn="ctr"/>
+            <a:endParaRPr/>
           </a:p>
         </p:txBody>
       </p:sp>
@@ -6147,7 +6196,7 @@
           <a:noFill/>
         </p:spPr>
         <p:txBody>
-          <a:bodyPr wrap="square" lIns="0" rIns="0" tIns="0" bIns="0" anchor="t">
+          <a:bodyPr wrap="square" lIns="0" tIns="0" rIns="0" bIns="0" anchor="t">
             <a:spAutoFit/>
           </a:bodyPr>
           <a:lstStyle/>
@@ -6190,7 +6239,7 @@
           <a:noFill/>
         </p:spPr>
         <p:txBody>
-          <a:bodyPr wrap="square" lIns="0" rIns="0" tIns="0" bIns="0" anchor="t">
+          <a:bodyPr wrap="square" lIns="0" tIns="0" rIns="0" bIns="0" anchor="t">
             <a:spAutoFit/>
           </a:bodyPr>
           <a:lstStyle/>
@@ -6225,7 +6274,7 @@
           <a:noFill/>
         </p:spPr>
         <p:txBody>
-          <a:bodyPr wrap="square" lIns="0" rIns="0" tIns="0" bIns="0" anchor="t">
+          <a:bodyPr wrap="square" lIns="0" tIns="0" rIns="0" bIns="0" anchor="t">
             <a:spAutoFit/>
           </a:bodyPr>
           <a:lstStyle/>
@@ -6264,7 +6313,7 @@
           <a:noFill/>
         </p:spPr>
         <p:txBody>
-          <a:bodyPr wrap="square" lIns="0" rIns="0" tIns="0" bIns="0" anchor="t">
+          <a:bodyPr wrap="square" lIns="0" tIns="0" rIns="0" bIns="0" anchor="t">
             <a:spAutoFit/>
           </a:bodyPr>
           <a:lstStyle/>
@@ -6299,7 +6348,7 @@
           <a:noFill/>
         </p:spPr>
         <p:txBody>
-          <a:bodyPr wrap="square" lIns="0" rIns="0" tIns="0" bIns="0" anchor="t">
+          <a:bodyPr wrap="square" lIns="0" tIns="0" rIns="0" bIns="0" anchor="t">
             <a:spAutoFit/>
           </a:bodyPr>
           <a:lstStyle/>
@@ -6338,7 +6387,7 @@
           <a:noFill/>
         </p:spPr>
         <p:txBody>
-          <a:bodyPr wrap="square" lIns="0" rIns="0" tIns="0" bIns="0" anchor="t">
+          <a:bodyPr wrap="square" lIns="0" tIns="0" rIns="0" bIns="0" anchor="t">
             <a:spAutoFit/>
           </a:bodyPr>
           <a:lstStyle/>
@@ -6373,7 +6422,7 @@
           <a:noFill/>
         </p:spPr>
         <p:txBody>
-          <a:bodyPr wrap="square" lIns="0" rIns="0" tIns="0" bIns="0" anchor="t">
+          <a:bodyPr wrap="square" lIns="0" tIns="0" rIns="0" bIns="0" anchor="t">
             <a:spAutoFit/>
           </a:bodyPr>
           <a:lstStyle/>
@@ -6436,6 +6485,7 @@
           <a:lstStyle/>
           <a:p>
             <a:pPr algn="ctr"/>
+            <a:endParaRPr/>
           </a:p>
         </p:txBody>
       </p:sp>
@@ -6456,7 +6506,7 @@
           <a:noFill/>
         </p:spPr>
         <p:txBody>
-          <a:bodyPr wrap="square" lIns="0" rIns="0" tIns="0" bIns="0" anchor="t">
+          <a:bodyPr wrap="square" lIns="0" tIns="0" rIns="0" bIns="0" anchor="t">
             <a:spAutoFit/>
           </a:bodyPr>
           <a:lstStyle/>
@@ -6483,7 +6533,7 @@
 </file>
 
 <file path=ppt/slides/slide4.xml><?xml version="1.0" encoding="utf-8"?>
-<p:sld xmlns:a="http://schemas.openxmlformats.org/drawingml/2006/main" xmlns:p="http://schemas.openxmlformats.org/presentationml/2006/main" xmlns:r="http://schemas.openxmlformats.org/officeDocument/2006/relationships">
+<p:sld xmlns:a="http://schemas.openxmlformats.org/drawingml/2006/main" xmlns:r="http://schemas.openxmlformats.org/officeDocument/2006/relationships" xmlns:p="http://schemas.openxmlformats.org/presentationml/2006/main">
   <p:cSld>
     <p:bg>
       <p:bgPr>
@@ -6499,7 +6549,14 @@
         <p:cNvGrpSpPr/>
         <p:nvPr/>
       </p:nvGrpSpPr>
-      <p:grpSpPr/>
+      <p:grpSpPr>
+        <a:xfrm>
+          <a:off x="0" y="0"/>
+          <a:ext cx="0" cy="0"/>
+          <a:chOff x="0" y="0"/>
+          <a:chExt cx="0" cy="0"/>
+        </a:xfrm>
+      </p:grpSpPr>
       <p:sp>
         <p:nvSpPr>
           <p:cNvPr id="2" name="TextBox 1"/>
@@ -6517,7 +6574,7 @@
           <a:noFill/>
         </p:spPr>
         <p:txBody>
-          <a:bodyPr wrap="square" lIns="0" rIns="0" tIns="0" bIns="0" anchor="t">
+          <a:bodyPr wrap="square" lIns="0" tIns="0" rIns="0" bIns="0" anchor="t">
             <a:spAutoFit/>
           </a:bodyPr>
           <a:lstStyle/>
@@ -6552,7 +6609,7 @@
           <a:noFill/>
         </p:spPr>
         <p:txBody>
-          <a:bodyPr wrap="square" lIns="0" rIns="0" tIns="0" bIns="0" anchor="t">
+          <a:bodyPr wrap="square" lIns="0" tIns="0" rIns="0" bIns="0" anchor="t">
             <a:spAutoFit/>
           </a:bodyPr>
           <a:lstStyle/>
@@ -6611,6 +6668,7 @@
           <a:lstStyle/>
           <a:p>
             <a:pPr algn="ctr"/>
+            <a:endParaRPr/>
           </a:p>
         </p:txBody>
       </p:sp>
@@ -6631,7 +6689,7 @@
           <a:noFill/>
         </p:spPr>
         <p:txBody>
-          <a:bodyPr wrap="square" lIns="0" rIns="0" tIns="0" bIns="0" anchor="t">
+          <a:bodyPr wrap="square" lIns="0" tIns="0" rIns="0" bIns="0" anchor="t">
             <a:spAutoFit/>
           </a:bodyPr>
           <a:lstStyle/>
@@ -6670,7 +6728,7 @@
           <a:noFill/>
         </p:spPr>
         <p:txBody>
-          <a:bodyPr wrap="square" lIns="0" rIns="0" tIns="0" bIns="0" anchor="t">
+          <a:bodyPr wrap="square" lIns="0" tIns="0" rIns="0" bIns="0" anchor="t">
             <a:spAutoFit/>
           </a:bodyPr>
           <a:lstStyle/>
@@ -6705,7 +6763,7 @@
           <a:noFill/>
         </p:spPr>
         <p:txBody>
-          <a:bodyPr wrap="square" lIns="0" rIns="0" tIns="0" bIns="0" anchor="t">
+          <a:bodyPr wrap="square" lIns="0" tIns="0" rIns="0" bIns="0" anchor="t">
             <a:spAutoFit/>
           </a:bodyPr>
           <a:lstStyle/>
@@ -6744,7 +6802,7 @@
           <a:noFill/>
         </p:spPr>
         <p:txBody>
-          <a:bodyPr wrap="square" lIns="0" rIns="0" tIns="0" bIns="0" anchor="t">
+          <a:bodyPr wrap="square" lIns="0" tIns="0" rIns="0" bIns="0" anchor="t">
             <a:spAutoFit/>
           </a:bodyPr>
           <a:lstStyle/>
@@ -6779,7 +6837,7 @@
           <a:noFill/>
         </p:spPr>
         <p:txBody>
-          <a:bodyPr wrap="square" lIns="0" rIns="0" tIns="0" bIns="0" anchor="t">
+          <a:bodyPr wrap="square" lIns="0" tIns="0" rIns="0" bIns="0" anchor="t">
             <a:spAutoFit/>
           </a:bodyPr>
           <a:lstStyle/>
@@ -6814,7 +6872,7 @@
           <a:noFill/>
         </p:spPr>
         <p:txBody>
-          <a:bodyPr wrap="square" lIns="0" rIns="0" tIns="0" bIns="0" anchor="t">
+          <a:bodyPr wrap="square" lIns="0" tIns="0" rIns="0" bIns="0" anchor="t">
             <a:spAutoFit/>
           </a:bodyPr>
           <a:lstStyle/>
@@ -6873,6 +6931,7 @@
           <a:lstStyle/>
           <a:p>
             <a:pPr algn="ctr"/>
+            <a:endParaRPr/>
           </a:p>
         </p:txBody>
       </p:sp>
@@ -6893,7 +6952,7 @@
           <a:noFill/>
         </p:spPr>
         <p:txBody>
-          <a:bodyPr wrap="square" lIns="0" rIns="0" tIns="0" bIns="0" anchor="t">
+          <a:bodyPr wrap="square" lIns="0" tIns="0" rIns="0" bIns="0" anchor="t">
             <a:spAutoFit/>
           </a:bodyPr>
           <a:lstStyle/>
@@ -6928,7 +6987,7 @@
           <a:noFill/>
         </p:spPr>
         <p:txBody>
-          <a:bodyPr wrap="square" lIns="0" rIns="0" tIns="0" bIns="0" anchor="t">
+          <a:bodyPr wrap="square" lIns="0" tIns="0" rIns="0" bIns="0" anchor="t">
             <a:spAutoFit/>
           </a:bodyPr>
           <a:lstStyle/>
@@ -6987,6 +7046,7 @@
           <a:lstStyle/>
           <a:p>
             <a:pPr algn="ctr"/>
+            <a:endParaRPr/>
           </a:p>
         </p:txBody>
       </p:sp>
@@ -7007,7 +7067,7 @@
           <a:noFill/>
         </p:spPr>
         <p:txBody>
-          <a:bodyPr wrap="square" lIns="0" rIns="0" tIns="0" bIns="0" anchor="t">
+          <a:bodyPr wrap="square" lIns="0" tIns="0" rIns="0" bIns="0" anchor="t">
             <a:spAutoFit/>
           </a:bodyPr>
           <a:lstStyle/>
@@ -7042,7 +7102,7 @@
           <a:noFill/>
         </p:spPr>
         <p:txBody>
-          <a:bodyPr wrap="square" lIns="0" rIns="0" tIns="0" bIns="0" anchor="t">
+          <a:bodyPr wrap="square" lIns="0" tIns="0" rIns="0" bIns="0" anchor="t">
             <a:spAutoFit/>
           </a:bodyPr>
           <a:lstStyle/>
@@ -7101,6 +7161,7 @@
           <a:lstStyle/>
           <a:p>
             <a:pPr algn="ctr"/>
+            <a:endParaRPr/>
           </a:p>
         </p:txBody>
       </p:sp>
@@ -7121,7 +7182,7 @@
           <a:noFill/>
         </p:spPr>
         <p:txBody>
-          <a:bodyPr wrap="square" lIns="0" rIns="0" tIns="0" bIns="0" anchor="t">
+          <a:bodyPr wrap="square" lIns="0" tIns="0" rIns="0" bIns="0" anchor="t">
             <a:spAutoFit/>
           </a:bodyPr>
           <a:lstStyle/>
@@ -7156,7 +7217,7 @@
           <a:noFill/>
         </p:spPr>
         <p:txBody>
-          <a:bodyPr wrap="square" lIns="0" rIns="0" tIns="0" bIns="0" anchor="t">
+          <a:bodyPr wrap="square" lIns="0" tIns="0" rIns="0" bIns="0" anchor="t">
             <a:spAutoFit/>
           </a:bodyPr>
           <a:lstStyle/>
@@ -7217,6 +7278,7 @@
           <a:lstStyle/>
           <a:p>
             <a:pPr algn="ctr"/>
+            <a:endParaRPr/>
           </a:p>
         </p:txBody>
       </p:sp>
@@ -7237,7 +7299,7 @@
           <a:noFill/>
         </p:spPr>
         <p:txBody>
-          <a:bodyPr wrap="square" lIns="0" rIns="0" tIns="0" bIns="0" anchor="t">
+          <a:bodyPr wrap="square" lIns="0" tIns="0" rIns="0" bIns="0" anchor="t">
             <a:spAutoFit/>
           </a:bodyPr>
           <a:lstStyle/>
@@ -7272,7 +7334,7 @@
           <a:noFill/>
         </p:spPr>
         <p:txBody>
-          <a:bodyPr wrap="square" lIns="0" rIns="0" tIns="0" bIns="0" anchor="t">
+          <a:bodyPr wrap="square" lIns="0" tIns="0" rIns="0" bIns="0" anchor="t">
             <a:spAutoFit/>
           </a:bodyPr>
           <a:lstStyle/>
@@ -7335,7 +7397,7 @@
           <a:noFill/>
         </p:spPr>
         <p:txBody>
-          <a:bodyPr wrap="square" lIns="0" rIns="0" tIns="0" bIns="0" anchor="t">
+          <a:bodyPr wrap="square" lIns="0" tIns="0" rIns="0" bIns="0" anchor="t">
             <a:spAutoFit/>
           </a:bodyPr>
           <a:lstStyle/>
@@ -7398,6 +7460,7 @@
           <a:lstStyle/>
           <a:p>
             <a:pPr algn="ctr"/>
+            <a:endParaRPr/>
           </a:p>
         </p:txBody>
       </p:sp>
@@ -7418,7 +7481,7 @@
           <a:noFill/>
         </p:spPr>
         <p:txBody>
-          <a:bodyPr wrap="square" lIns="0" rIns="0" tIns="0" bIns="0" anchor="t">
+          <a:bodyPr wrap="square" lIns="0" tIns="0" rIns="0" bIns="0" anchor="t">
             <a:spAutoFit/>
           </a:bodyPr>
           <a:lstStyle/>
@@ -7445,7 +7508,7 @@
 </file>
 
 <file path=ppt/slides/slide5.xml><?xml version="1.0" encoding="utf-8"?>
-<p:sld xmlns:a="http://schemas.openxmlformats.org/drawingml/2006/main" xmlns:p="http://schemas.openxmlformats.org/presentationml/2006/main" xmlns:r="http://schemas.openxmlformats.org/officeDocument/2006/relationships">
+<p:sld xmlns:a="http://schemas.openxmlformats.org/drawingml/2006/main" xmlns:r="http://schemas.openxmlformats.org/officeDocument/2006/relationships" xmlns:p="http://schemas.openxmlformats.org/presentationml/2006/main">
   <p:cSld>
     <p:bg>
       <p:bgPr>
@@ -7461,7 +7524,14 @@
         <p:cNvGrpSpPr/>
         <p:nvPr/>
       </p:nvGrpSpPr>
-      <p:grpSpPr/>
+      <p:grpSpPr>
+        <a:xfrm>
+          <a:off x="0" y="0"/>
+          <a:ext cx="0" cy="0"/>
+          <a:chOff x="0" y="0"/>
+          <a:chExt cx="0" cy="0"/>
+        </a:xfrm>
+      </p:grpSpPr>
       <p:sp>
         <p:nvSpPr>
           <p:cNvPr id="2" name="TextBox 1"/>
@@ -7479,7 +7549,7 @@
           <a:noFill/>
         </p:spPr>
         <p:txBody>
-          <a:bodyPr wrap="square" lIns="0" rIns="0" tIns="0" bIns="0" anchor="t">
+          <a:bodyPr wrap="square" lIns="0" tIns="0" rIns="0" bIns="0" anchor="t">
             <a:spAutoFit/>
           </a:bodyPr>
           <a:lstStyle/>
@@ -7514,7 +7584,7 @@
           <a:noFill/>
         </p:spPr>
         <p:txBody>
-          <a:bodyPr wrap="square" lIns="0" rIns="0" tIns="0" bIns="0" anchor="t">
+          <a:bodyPr wrap="square" lIns="0" tIns="0" rIns="0" bIns="0" anchor="t">
             <a:spAutoFit/>
           </a:bodyPr>
           <a:lstStyle/>
@@ -7573,6 +7643,7 @@
           <a:lstStyle/>
           <a:p>
             <a:pPr algn="ctr"/>
+            <a:endParaRPr/>
           </a:p>
         </p:txBody>
       </p:sp>
@@ -7593,7 +7664,7 @@
           <a:noFill/>
         </p:spPr>
         <p:txBody>
-          <a:bodyPr wrap="square" lIns="0" rIns="0" tIns="0" bIns="0" anchor="t">
+          <a:bodyPr wrap="square" lIns="0" tIns="0" rIns="0" bIns="0" anchor="t">
             <a:spAutoFit/>
           </a:bodyPr>
           <a:lstStyle/>
@@ -7632,7 +7703,7 @@
           <a:noFill/>
         </p:spPr>
         <p:txBody>
-          <a:bodyPr wrap="square" lIns="0" rIns="0" tIns="0" bIns="0" anchor="t">
+          <a:bodyPr wrap="square" lIns="0" tIns="0" rIns="0" bIns="0" anchor="t">
             <a:spAutoFit/>
           </a:bodyPr>
           <a:lstStyle/>
@@ -7669,14 +7740,32 @@
                 <a:tableStyleId>{5C22544A-7EE6-4342-B048-85BDC9FD1C3A}</a:tableStyleId>
               </a:tblPr>
               <a:tblGrid>
-                <a:gridCol w="3238500"/>
-                <a:gridCol w="1600200"/>
-                <a:gridCol w="1562100"/>
+                <a:gridCol w="3238500">
+                  <a:extLst>
+                    <a:ext uri="{9D8B030D-6E8A-4147-A177-3AD203B41FA5}">
+                      <a16:colId xmlns:a16="http://schemas.microsoft.com/office/drawing/2014/main" val="20000"/>
+                    </a:ext>
+                  </a:extLst>
+                </a:gridCol>
+                <a:gridCol w="1600200">
+                  <a:extLst>
+                    <a:ext uri="{9D8B030D-6E8A-4147-A177-3AD203B41FA5}">
+                      <a16:colId xmlns:a16="http://schemas.microsoft.com/office/drawing/2014/main" val="20001"/>
+                    </a:ext>
+                  </a:extLst>
+                </a:gridCol>
+                <a:gridCol w="1562100">
+                  <a:extLst>
+                    <a:ext uri="{9D8B030D-6E8A-4147-A177-3AD203B41FA5}">
+                      <a16:colId xmlns:a16="http://schemas.microsoft.com/office/drawing/2014/main" val="20002"/>
+                    </a:ext>
+                  </a:extLst>
+                </a:gridCol>
               </a:tblGrid>
               <a:tr h="381000">
                 <a:tc>
                   <a:txBody>
-                    <a:bodyPr wrap="square"/>
+                    <a:bodyPr/>
                     <a:lstStyle/>
                     <a:p>
                       <a:pPr algn="l">
@@ -7708,7 +7797,7 @@
                 </a:tc>
                 <a:tc>
                   <a:txBody>
-                    <a:bodyPr wrap="square"/>
+                    <a:bodyPr/>
                     <a:lstStyle/>
                     <a:p>
                       <a:pPr algn="r">
@@ -7740,7 +7829,7 @@
                 </a:tc>
                 <a:tc>
                   <a:txBody>
-                    <a:bodyPr wrap="square"/>
+                    <a:bodyPr/>
                     <a:lstStyle/>
                     <a:p>
                       <a:pPr algn="r">
@@ -7770,11 +7859,16 @@
                     </a:solidFill>
                   </a:tcPr>
                 </a:tc>
+                <a:extLst>
+                  <a:ext uri="{0D108BD9-81ED-4DB2-BD59-A6C34878D82A}">
+                    <a16:rowId xmlns:a16="http://schemas.microsoft.com/office/drawing/2014/main" val="10000"/>
+                  </a:ext>
+                </a:extLst>
               </a:tr>
               <a:tr h="495300">
                 <a:tc>
                   <a:txBody>
-                    <a:bodyPr wrap="square"/>
+                    <a:bodyPr/>
                     <a:lstStyle/>
                     <a:p>
                       <a:pPr algn="l">
@@ -7794,6 +7888,15 @@
                     </a:p>
                   </a:txBody>
                   <a:tcPr marL="0" marR="95250" marT="57150" marB="57150" anchor="ctr">
+                    <a:lnT w="25400" cap="flat" cmpd="sng" algn="ctr">
+                      <a:solidFill>
+                        <a:srgbClr val="1F3A5F"/>
+                      </a:solidFill>
+                      <a:prstDash val="solid"/>
+                      <a:round/>
+                      <a:headEnd type="none" w="med" len="med"/>
+                      <a:tailEnd type="none" w="med" len="med"/>
+                    </a:lnT>
                     <a:lnB w="12700" cap="flat" cmpd="sng" algn="ctr">
                       <a:solidFill>
                         <a:srgbClr val="D8DEE6"/>
@@ -7806,7 +7909,7 @@
                 </a:tc>
                 <a:tc>
                   <a:txBody>
-                    <a:bodyPr wrap="square"/>
+                    <a:bodyPr/>
                     <a:lstStyle/>
                     <a:p>
                       <a:pPr algn="r">
@@ -7826,6 +7929,15 @@
                     </a:p>
                   </a:txBody>
                   <a:tcPr marL="95250" marR="0" marT="57150" marB="57150" anchor="ctr">
+                    <a:lnT w="25400" cap="flat" cmpd="sng" algn="ctr">
+                      <a:solidFill>
+                        <a:srgbClr val="1F3A5F"/>
+                      </a:solidFill>
+                      <a:prstDash val="solid"/>
+                      <a:round/>
+                      <a:headEnd type="none" w="med" len="med"/>
+                      <a:tailEnd type="none" w="med" len="med"/>
+                    </a:lnT>
                     <a:lnB w="12700" cap="flat" cmpd="sng" algn="ctr">
                       <a:solidFill>
                         <a:srgbClr val="D8DEE6"/>
@@ -7838,7 +7950,7 @@
                 </a:tc>
                 <a:tc>
                   <a:txBody>
-                    <a:bodyPr wrap="square"/>
+                    <a:bodyPr/>
                     <a:lstStyle/>
                     <a:p>
                       <a:pPr algn="r">
@@ -7858,6 +7970,15 @@
                     </a:p>
                   </a:txBody>
                   <a:tcPr marL="95250" marR="0" marT="57150" marB="57150" anchor="ctr">
+                    <a:lnT w="25400" cap="flat" cmpd="sng" algn="ctr">
+                      <a:solidFill>
+                        <a:srgbClr val="1F3A5F"/>
+                      </a:solidFill>
+                      <a:prstDash val="solid"/>
+                      <a:round/>
+                      <a:headEnd type="none" w="med" len="med"/>
+                      <a:tailEnd type="none" w="med" len="med"/>
+                    </a:lnT>
                     <a:lnB w="12700" cap="flat" cmpd="sng" algn="ctr">
                       <a:solidFill>
                         <a:srgbClr val="D8DEE6"/>
@@ -7868,11 +7989,16 @@
                     </a:solidFill>
                   </a:tcPr>
                 </a:tc>
+                <a:extLst>
+                  <a:ext uri="{0D108BD9-81ED-4DB2-BD59-A6C34878D82A}">
+                    <a16:rowId xmlns:a16="http://schemas.microsoft.com/office/drawing/2014/main" val="10001"/>
+                  </a:ext>
+                </a:extLst>
               </a:tr>
               <a:tr h="495300">
                 <a:tc>
                   <a:txBody>
-                    <a:bodyPr wrap="square"/>
+                    <a:bodyPr/>
                     <a:lstStyle/>
                     <a:p>
                       <a:pPr algn="l">
@@ -7892,6 +8018,15 @@
                     </a:p>
                   </a:txBody>
                   <a:tcPr marL="0" marR="95250" marT="57150" marB="57150" anchor="ctr">
+                    <a:lnT w="12700" cap="flat" cmpd="sng" algn="ctr">
+                      <a:solidFill>
+                        <a:srgbClr val="D8DEE6"/>
+                      </a:solidFill>
+                      <a:prstDash val="solid"/>
+                      <a:round/>
+                      <a:headEnd type="none" w="med" len="med"/>
+                      <a:tailEnd type="none" w="med" len="med"/>
+                    </a:lnT>
                     <a:lnB w="12700" cap="flat" cmpd="sng" algn="ctr">
                       <a:solidFill>
                         <a:srgbClr val="D8DEE6"/>
@@ -7904,7 +8039,7 @@
                 </a:tc>
                 <a:tc>
                   <a:txBody>
-                    <a:bodyPr wrap="square"/>
+                    <a:bodyPr/>
                     <a:lstStyle/>
                     <a:p>
                       <a:pPr algn="r">
@@ -7924,6 +8059,15 @@
                     </a:p>
                   </a:txBody>
                   <a:tcPr marL="95250" marR="0" marT="57150" marB="57150" anchor="ctr">
+                    <a:lnT w="12700" cap="flat" cmpd="sng" algn="ctr">
+                      <a:solidFill>
+                        <a:srgbClr val="D8DEE6"/>
+                      </a:solidFill>
+                      <a:prstDash val="solid"/>
+                      <a:round/>
+                      <a:headEnd type="none" w="med" len="med"/>
+                      <a:tailEnd type="none" w="med" len="med"/>
+                    </a:lnT>
                     <a:lnB w="12700" cap="flat" cmpd="sng" algn="ctr">
                       <a:solidFill>
                         <a:srgbClr val="D8DEE6"/>
@@ -7936,7 +8080,7 @@
                 </a:tc>
                 <a:tc>
                   <a:txBody>
-                    <a:bodyPr wrap="square"/>
+                    <a:bodyPr/>
                     <a:lstStyle/>
                     <a:p>
                       <a:pPr algn="r">
@@ -7956,6 +8100,15 @@
                     </a:p>
                   </a:txBody>
                   <a:tcPr marL="95250" marR="0" marT="57150" marB="57150" anchor="ctr">
+                    <a:lnT w="12700" cap="flat" cmpd="sng" algn="ctr">
+                      <a:solidFill>
+                        <a:srgbClr val="D8DEE6"/>
+                      </a:solidFill>
+                      <a:prstDash val="solid"/>
+                      <a:round/>
+                      <a:headEnd type="none" w="med" len="med"/>
+                      <a:tailEnd type="none" w="med" len="med"/>
+                    </a:lnT>
                     <a:lnB w="12700" cap="flat" cmpd="sng" algn="ctr">
                       <a:solidFill>
                         <a:srgbClr val="D8DEE6"/>
@@ -7966,11 +8119,16 @@
                     </a:solidFill>
                   </a:tcPr>
                 </a:tc>
+                <a:extLst>
+                  <a:ext uri="{0D108BD9-81ED-4DB2-BD59-A6C34878D82A}">
+                    <a16:rowId xmlns:a16="http://schemas.microsoft.com/office/drawing/2014/main" val="10002"/>
+                  </a:ext>
+                </a:extLst>
               </a:tr>
               <a:tr h="495300">
                 <a:tc>
                   <a:txBody>
-                    <a:bodyPr wrap="square"/>
+                    <a:bodyPr/>
                     <a:lstStyle/>
                     <a:p>
                       <a:pPr algn="l">
@@ -7990,6 +8148,15 @@
                     </a:p>
                   </a:txBody>
                   <a:tcPr marL="0" marR="95250" marT="57150" marB="57150" anchor="ctr">
+                    <a:lnT w="12700" cap="flat" cmpd="sng" algn="ctr">
+                      <a:solidFill>
+                        <a:srgbClr val="D8DEE6"/>
+                      </a:solidFill>
+                      <a:prstDash val="solid"/>
+                      <a:round/>
+                      <a:headEnd type="none" w="med" len="med"/>
+                      <a:tailEnd type="none" w="med" len="med"/>
+                    </a:lnT>
                     <a:lnB w="12700" cap="flat" cmpd="sng" algn="ctr">
                       <a:solidFill>
                         <a:srgbClr val="D8DEE6"/>
@@ -8002,7 +8169,7 @@
                 </a:tc>
                 <a:tc>
                   <a:txBody>
-                    <a:bodyPr wrap="square"/>
+                    <a:bodyPr/>
                     <a:lstStyle/>
                     <a:p>
                       <a:pPr algn="r">
@@ -8022,6 +8189,15 @@
                     </a:p>
                   </a:txBody>
                   <a:tcPr marL="95250" marR="0" marT="57150" marB="57150" anchor="ctr">
+                    <a:lnT w="12700" cap="flat" cmpd="sng" algn="ctr">
+                      <a:solidFill>
+                        <a:srgbClr val="D8DEE6"/>
+                      </a:solidFill>
+                      <a:prstDash val="solid"/>
+                      <a:round/>
+                      <a:headEnd type="none" w="med" len="med"/>
+                      <a:tailEnd type="none" w="med" len="med"/>
+                    </a:lnT>
                     <a:lnB w="12700" cap="flat" cmpd="sng" algn="ctr">
                       <a:solidFill>
                         <a:srgbClr val="D8DEE6"/>
@@ -8034,7 +8210,7 @@
                 </a:tc>
                 <a:tc>
                   <a:txBody>
-                    <a:bodyPr wrap="square"/>
+                    <a:bodyPr/>
                     <a:lstStyle/>
                     <a:p>
                       <a:pPr algn="r">
@@ -8054,6 +8230,15 @@
                     </a:p>
                   </a:txBody>
                   <a:tcPr marL="95250" marR="0" marT="57150" marB="57150" anchor="ctr">
+                    <a:lnT w="12700" cap="flat" cmpd="sng" algn="ctr">
+                      <a:solidFill>
+                        <a:srgbClr val="D8DEE6"/>
+                      </a:solidFill>
+                      <a:prstDash val="solid"/>
+                      <a:round/>
+                      <a:headEnd type="none" w="med" len="med"/>
+                      <a:tailEnd type="none" w="med" len="med"/>
+                    </a:lnT>
                     <a:lnB w="12700" cap="flat" cmpd="sng" algn="ctr">
                       <a:solidFill>
                         <a:srgbClr val="D8DEE6"/>
@@ -8064,6 +8249,11 @@
                     </a:solidFill>
                   </a:tcPr>
                 </a:tc>
+                <a:extLst>
+                  <a:ext uri="{0D108BD9-81ED-4DB2-BD59-A6C34878D82A}">
+                    <a16:rowId xmlns:a16="http://schemas.microsoft.com/office/drawing/2014/main" val="10003"/>
+                  </a:ext>
+                </a:extLst>
               </a:tr>
             </a:tbl>
           </a:graphicData>
@@ -8110,6 +8300,7 @@
           <a:lstStyle/>
           <a:p>
             <a:pPr algn="ctr"/>
+            <a:endParaRPr/>
           </a:p>
         </p:txBody>
       </p:sp>
@@ -8130,7 +8321,7 @@
           <a:noFill/>
         </p:spPr>
         <p:txBody>
-          <a:bodyPr wrap="square" lIns="0" rIns="0" tIns="0" bIns="0" anchor="t">
+          <a:bodyPr wrap="square" lIns="0" tIns="0" rIns="0" bIns="0" anchor="t">
             <a:spAutoFit/>
           </a:bodyPr>
           <a:lstStyle/>
@@ -8193,6 +8384,7 @@
           <a:lstStyle/>
           <a:p>
             <a:pPr algn="ctr"/>
+            <a:endParaRPr/>
           </a:p>
         </p:txBody>
       </p:sp>
@@ -8237,6 +8429,7 @@
           <a:lstStyle/>
           <a:p>
             <a:pPr algn="ctr"/>
+            <a:endParaRPr/>
           </a:p>
         </p:txBody>
       </p:sp>
@@ -8257,7 +8450,7 @@
           <a:noFill/>
         </p:spPr>
         <p:txBody>
-          <a:bodyPr wrap="square" lIns="0" rIns="0" tIns="0" bIns="0" anchor="t">
+          <a:bodyPr wrap="square" lIns="0" tIns="0" rIns="0" bIns="0" anchor="t">
             <a:spAutoFit/>
           </a:bodyPr>
           <a:lstStyle/>
@@ -8344,6 +8537,7 @@
           <a:lstStyle/>
           <a:p>
             <a:pPr algn="ctr"/>
+            <a:endParaRPr/>
           </a:p>
         </p:txBody>
       </p:sp>
@@ -8364,7 +8558,7 @@
           <a:noFill/>
         </p:spPr>
         <p:txBody>
-          <a:bodyPr wrap="square" lIns="0" rIns="0" tIns="0" bIns="0" anchor="t">
+          <a:bodyPr wrap="square" lIns="0" tIns="0" rIns="0" bIns="0" anchor="t">
             <a:spAutoFit/>
           </a:bodyPr>
           <a:lstStyle/>
@@ -8391,7 +8585,7 @@
 </file>
 
 <file path=ppt/slides/slide6.xml><?xml version="1.0" encoding="utf-8"?>
-<p:sld xmlns:a="http://schemas.openxmlformats.org/drawingml/2006/main" xmlns:p="http://schemas.openxmlformats.org/presentationml/2006/main" xmlns:r="http://schemas.openxmlformats.org/officeDocument/2006/relationships">
+<p:sld xmlns:a="http://schemas.openxmlformats.org/drawingml/2006/main" xmlns:r="http://schemas.openxmlformats.org/officeDocument/2006/relationships" xmlns:p="http://schemas.openxmlformats.org/presentationml/2006/main">
   <p:cSld>
     <p:bg>
       <p:bgPr>
@@ -8407,7 +8601,14 @@
         <p:cNvGrpSpPr/>
         <p:nvPr/>
       </p:nvGrpSpPr>
-      <p:grpSpPr/>
+      <p:grpSpPr>
+        <a:xfrm>
+          <a:off x="0" y="0"/>
+          <a:ext cx="0" cy="0"/>
+          <a:chOff x="0" y="0"/>
+          <a:chExt cx="0" cy="0"/>
+        </a:xfrm>
+      </p:grpSpPr>
       <p:sp>
         <p:nvSpPr>
           <p:cNvPr id="2" name="TextBox 1"/>
@@ -8425,7 +8626,7 @@
           <a:noFill/>
         </p:spPr>
         <p:txBody>
-          <a:bodyPr wrap="square" lIns="0" rIns="0" tIns="0" bIns="0" anchor="t">
+          <a:bodyPr wrap="square" lIns="0" tIns="0" rIns="0" bIns="0" anchor="t">
             <a:spAutoFit/>
           </a:bodyPr>
           <a:lstStyle/>
@@ -8460,7 +8661,7 @@
           <a:noFill/>
         </p:spPr>
         <p:txBody>
-          <a:bodyPr wrap="square" lIns="0" rIns="0" tIns="0" bIns="0" anchor="t">
+          <a:bodyPr wrap="square" lIns="0" tIns="0" rIns="0" bIns="0" anchor="t">
             <a:spAutoFit/>
           </a:bodyPr>
           <a:lstStyle/>
@@ -8519,6 +8720,7 @@
           <a:lstStyle/>
           <a:p>
             <a:pPr algn="ctr"/>
+            <a:endParaRPr/>
           </a:p>
         </p:txBody>
       </p:sp>
@@ -8563,6 +8765,7 @@
           <a:lstStyle/>
           <a:p>
             <a:pPr algn="ctr"/>
+            <a:endParaRPr/>
           </a:p>
         </p:txBody>
       </p:sp>
@@ -8609,6 +8812,7 @@
           <a:lstStyle/>
           <a:p>
             <a:pPr algn="ctr"/>
+            <a:endParaRPr/>
           </a:p>
         </p:txBody>
       </p:sp>
@@ -8629,7 +8833,7 @@
           <a:noFill/>
         </p:spPr>
         <p:txBody>
-          <a:bodyPr wrap="square" lIns="0" rIns="0" tIns="0" bIns="0" anchor="t">
+          <a:bodyPr wrap="square" lIns="0" tIns="0" rIns="0" bIns="0" anchor="t">
             <a:spAutoFit/>
           </a:bodyPr>
           <a:lstStyle/>
@@ -8664,7 +8868,7 @@
           <a:noFill/>
         </p:spPr>
         <p:txBody>
-          <a:bodyPr wrap="square" lIns="0" rIns="0" tIns="0" bIns="0" anchor="t">
+          <a:bodyPr wrap="square" lIns="0" tIns="0" rIns="0" bIns="0" anchor="t">
             <a:spAutoFit/>
           </a:bodyPr>
           <a:lstStyle/>
@@ -8699,7 +8903,7 @@
           <a:noFill/>
         </p:spPr>
         <p:txBody>
-          <a:bodyPr wrap="square" lIns="0" rIns="0" tIns="0" bIns="0" anchor="t">
+          <a:bodyPr wrap="square" lIns="0" tIns="0" rIns="0" bIns="0" anchor="t">
             <a:spAutoFit/>
           </a:bodyPr>
           <a:lstStyle/>
@@ -8731,7 +8935,7 @@
         </p:nvGraphicFramePr>
         <p:xfrm>
           <a:off x="685800" y="2209800"/>
-          <a:ext cx="7581900" cy="2095500"/>
+          <a:ext cx="7581900" cy="2097405"/>
         </p:xfrm>
         <a:graphic>
           <a:graphicData uri="http://schemas.openxmlformats.org/drawingml/2006/table">
@@ -8740,15 +8944,39 @@
                 <a:tableStyleId>{5C22544A-7EE6-4342-B048-85BDC9FD1C3A}</a:tableStyleId>
               </a:tblPr>
               <a:tblGrid>
-                <a:gridCol w="1905000"/>
-                <a:gridCol w="1600200"/>
-                <a:gridCol w="2057400"/>
-                <a:gridCol w="2019300"/>
+                <a:gridCol w="1905000">
+                  <a:extLst>
+                    <a:ext uri="{9D8B030D-6E8A-4147-A177-3AD203B41FA5}">
+                      <a16:colId xmlns:a16="http://schemas.microsoft.com/office/drawing/2014/main" val="20000"/>
+                    </a:ext>
+                  </a:extLst>
+                </a:gridCol>
+                <a:gridCol w="1600200">
+                  <a:extLst>
+                    <a:ext uri="{9D8B030D-6E8A-4147-A177-3AD203B41FA5}">
+                      <a16:colId xmlns:a16="http://schemas.microsoft.com/office/drawing/2014/main" val="20001"/>
+                    </a:ext>
+                  </a:extLst>
+                </a:gridCol>
+                <a:gridCol w="2057400">
+                  <a:extLst>
+                    <a:ext uri="{9D8B030D-6E8A-4147-A177-3AD203B41FA5}">
+                      <a16:colId xmlns:a16="http://schemas.microsoft.com/office/drawing/2014/main" val="20002"/>
+                    </a:ext>
+                  </a:extLst>
+                </a:gridCol>
+                <a:gridCol w="2019300">
+                  <a:extLst>
+                    <a:ext uri="{9D8B030D-6E8A-4147-A177-3AD203B41FA5}">
+                      <a16:colId xmlns:a16="http://schemas.microsoft.com/office/drawing/2014/main" val="20003"/>
+                    </a:ext>
+                  </a:extLst>
+                </a:gridCol>
               </a:tblGrid>
               <a:tr h="552450">
                 <a:tc>
                   <a:txBody>
-                    <a:bodyPr wrap="square"/>
+                    <a:bodyPr/>
                     <a:lstStyle/>
                     <a:p>
                       <a:pPr algn="l">
@@ -8792,7 +9020,7 @@
                 </a:tc>
                 <a:tc>
                   <a:txBody>
-                    <a:bodyPr wrap="square"/>
+                    <a:bodyPr/>
                     <a:lstStyle/>
                     <a:p>
                       <a:pPr algn="r">
@@ -8836,7 +9064,7 @@
                 </a:tc>
                 <a:tc>
                   <a:txBody>
-                    <a:bodyPr wrap="square"/>
+                    <a:bodyPr/>
                     <a:lstStyle/>
                     <a:p>
                       <a:pPr algn="r">
@@ -8880,7 +9108,7 @@
                 </a:tc>
                 <a:tc>
                   <a:txBody>
-                    <a:bodyPr wrap="square"/>
+                    <a:bodyPr/>
                     <a:lstStyle/>
                     <a:p>
                       <a:pPr algn="r">
@@ -8922,11 +9150,16 @@
                     </a:solidFill>
                   </a:tcPr>
                 </a:tc>
+                <a:extLst>
+                  <a:ext uri="{0D108BD9-81ED-4DB2-BD59-A6C34878D82A}">
+                    <a16:rowId xmlns:a16="http://schemas.microsoft.com/office/drawing/2014/main" val="10000"/>
+                  </a:ext>
+                </a:extLst>
               </a:tr>
               <a:tr h="514350">
                 <a:tc>
                   <a:txBody>
-                    <a:bodyPr wrap="square"/>
+                    <a:bodyPr/>
                     <a:lstStyle/>
                     <a:p>
                       <a:pPr algn="l">
@@ -8946,6 +9179,15 @@
                     </a:p>
                   </a:txBody>
                   <a:tcPr marL="0" marR="95250" marT="57150" marB="57150" anchor="ctr">
+                    <a:lnT w="25400" cap="flat" cmpd="sng" algn="ctr">
+                      <a:solidFill>
+                        <a:srgbClr val="1F3A5F"/>
+                      </a:solidFill>
+                      <a:prstDash val="solid"/>
+                      <a:round/>
+                      <a:headEnd type="none" w="med" len="med"/>
+                      <a:tailEnd type="none" w="med" len="med"/>
+                    </a:lnT>
                     <a:lnB w="12700" cap="flat" cmpd="sng" algn="ctr">
                       <a:solidFill>
                         <a:srgbClr val="D8DEE6"/>
@@ -8958,7 +9200,7 @@
                 </a:tc>
                 <a:tc>
                   <a:txBody>
-                    <a:bodyPr wrap="square"/>
+                    <a:bodyPr/>
                     <a:lstStyle/>
                     <a:p>
                       <a:pPr algn="r">
@@ -8978,6 +9220,15 @@
                     </a:p>
                   </a:txBody>
                   <a:tcPr marL="95250" marR="0" marT="57150" marB="57150" anchor="ctr">
+                    <a:lnT w="25400" cap="flat" cmpd="sng" algn="ctr">
+                      <a:solidFill>
+                        <a:srgbClr val="1F3A5F"/>
+                      </a:solidFill>
+                      <a:prstDash val="solid"/>
+                      <a:round/>
+                      <a:headEnd type="none" w="med" len="med"/>
+                      <a:tailEnd type="none" w="med" len="med"/>
+                    </a:lnT>
                     <a:lnB w="12700" cap="flat" cmpd="sng" algn="ctr">
                       <a:solidFill>
                         <a:srgbClr val="D8DEE6"/>
@@ -8990,7 +9241,7 @@
                 </a:tc>
                 <a:tc>
                   <a:txBody>
-                    <a:bodyPr wrap="square"/>
+                    <a:bodyPr/>
                     <a:lstStyle/>
                     <a:p>
                       <a:pPr algn="r">
@@ -9010,6 +9261,15 @@
                     </a:p>
                   </a:txBody>
                   <a:tcPr marL="95250" marR="0" marT="57150" marB="57150" anchor="ctr">
+                    <a:lnT w="25400" cap="flat" cmpd="sng" algn="ctr">
+                      <a:solidFill>
+                        <a:srgbClr val="1F3A5F"/>
+                      </a:solidFill>
+                      <a:prstDash val="solid"/>
+                      <a:round/>
+                      <a:headEnd type="none" w="med" len="med"/>
+                      <a:tailEnd type="none" w="med" len="med"/>
+                    </a:lnT>
                     <a:lnB w="12700" cap="flat" cmpd="sng" algn="ctr">
                       <a:solidFill>
                         <a:srgbClr val="D8DEE6"/>
@@ -9022,7 +9282,7 @@
                 </a:tc>
                 <a:tc>
                   <a:txBody>
-                    <a:bodyPr wrap="square"/>
+                    <a:bodyPr/>
                     <a:lstStyle/>
                     <a:p>
                       <a:pPr algn="r">
@@ -9042,6 +9302,15 @@
                     </a:p>
                   </a:txBody>
                   <a:tcPr marL="95250" marR="0" marT="57150" marB="57150" anchor="ctr">
+                    <a:lnT w="25400" cap="flat" cmpd="sng" algn="ctr">
+                      <a:solidFill>
+                        <a:srgbClr val="1F3A5F"/>
+                      </a:solidFill>
+                      <a:prstDash val="solid"/>
+                      <a:round/>
+                      <a:headEnd type="none" w="med" len="med"/>
+                      <a:tailEnd type="none" w="med" len="med"/>
+                    </a:lnT>
                     <a:lnB w="12700" cap="flat" cmpd="sng" algn="ctr">
                       <a:solidFill>
                         <a:srgbClr val="D8DEE6"/>
@@ -9052,11 +9321,16 @@
                     </a:solidFill>
                   </a:tcPr>
                 </a:tc>
+                <a:extLst>
+                  <a:ext uri="{0D108BD9-81ED-4DB2-BD59-A6C34878D82A}">
+                    <a16:rowId xmlns:a16="http://schemas.microsoft.com/office/drawing/2014/main" val="10001"/>
+                  </a:ext>
+                </a:extLst>
               </a:tr>
               <a:tr h="514350">
                 <a:tc>
                   <a:txBody>
-                    <a:bodyPr wrap="square"/>
+                    <a:bodyPr/>
                     <a:lstStyle/>
                     <a:p>
                       <a:pPr algn="l">
@@ -9076,6 +9350,15 @@
                     </a:p>
                   </a:txBody>
                   <a:tcPr marL="0" marR="95250" marT="57150" marB="57150" anchor="ctr">
+                    <a:lnT w="12700" cap="flat" cmpd="sng" algn="ctr">
+                      <a:solidFill>
+                        <a:srgbClr val="D8DEE6"/>
+                      </a:solidFill>
+                      <a:prstDash val="solid"/>
+                      <a:round/>
+                      <a:headEnd type="none" w="med" len="med"/>
+                      <a:tailEnd type="none" w="med" len="med"/>
+                    </a:lnT>
                     <a:lnB w="12700" cap="flat" cmpd="sng" algn="ctr">
                       <a:solidFill>
                         <a:srgbClr val="D8DEE6"/>
@@ -9088,7 +9371,7 @@
                 </a:tc>
                 <a:tc>
                   <a:txBody>
-                    <a:bodyPr wrap="square"/>
+                    <a:bodyPr/>
                     <a:lstStyle/>
                     <a:p>
                       <a:pPr algn="r">
@@ -9108,6 +9391,15 @@
                     </a:p>
                   </a:txBody>
                   <a:tcPr marL="95250" marR="0" marT="57150" marB="57150" anchor="ctr">
+                    <a:lnT w="12700" cap="flat" cmpd="sng" algn="ctr">
+                      <a:solidFill>
+                        <a:srgbClr val="D8DEE6"/>
+                      </a:solidFill>
+                      <a:prstDash val="solid"/>
+                      <a:round/>
+                      <a:headEnd type="none" w="med" len="med"/>
+                      <a:tailEnd type="none" w="med" len="med"/>
+                    </a:lnT>
                     <a:lnB w="12700" cap="flat" cmpd="sng" algn="ctr">
                       <a:solidFill>
                         <a:srgbClr val="D8DEE6"/>
@@ -9120,7 +9412,7 @@
                 </a:tc>
                 <a:tc>
                   <a:txBody>
-                    <a:bodyPr wrap="square"/>
+                    <a:bodyPr/>
                     <a:lstStyle/>
                     <a:p>
                       <a:pPr algn="r">
@@ -9140,6 +9432,15 @@
                     </a:p>
                   </a:txBody>
                   <a:tcPr marL="95250" marR="0" marT="57150" marB="57150" anchor="ctr">
+                    <a:lnT w="12700" cap="flat" cmpd="sng" algn="ctr">
+                      <a:solidFill>
+                        <a:srgbClr val="D8DEE6"/>
+                      </a:solidFill>
+                      <a:prstDash val="solid"/>
+                      <a:round/>
+                      <a:headEnd type="none" w="med" len="med"/>
+                      <a:tailEnd type="none" w="med" len="med"/>
+                    </a:lnT>
                     <a:lnB w="12700" cap="flat" cmpd="sng" algn="ctr">
                       <a:solidFill>
                         <a:srgbClr val="D8DEE6"/>
@@ -9152,7 +9453,7 @@
                 </a:tc>
                 <a:tc>
                   <a:txBody>
-                    <a:bodyPr wrap="square"/>
+                    <a:bodyPr/>
                     <a:lstStyle/>
                     <a:p>
                       <a:pPr algn="r">
@@ -9172,6 +9473,15 @@
                     </a:p>
                   </a:txBody>
                   <a:tcPr marL="95250" marR="0" marT="57150" marB="57150" anchor="ctr">
+                    <a:lnT w="12700" cap="flat" cmpd="sng" algn="ctr">
+                      <a:solidFill>
+                        <a:srgbClr val="D8DEE6"/>
+                      </a:solidFill>
+                      <a:prstDash val="solid"/>
+                      <a:round/>
+                      <a:headEnd type="none" w="med" len="med"/>
+                      <a:tailEnd type="none" w="med" len="med"/>
+                    </a:lnT>
                     <a:lnB w="12700" cap="flat" cmpd="sng" algn="ctr">
                       <a:solidFill>
                         <a:srgbClr val="D8DEE6"/>
@@ -9182,11 +9492,16 @@
                     </a:solidFill>
                   </a:tcPr>
                 </a:tc>
+                <a:extLst>
+                  <a:ext uri="{0D108BD9-81ED-4DB2-BD59-A6C34878D82A}">
+                    <a16:rowId xmlns:a16="http://schemas.microsoft.com/office/drawing/2014/main" val="10002"/>
+                  </a:ext>
+                </a:extLst>
               </a:tr>
               <a:tr h="514350">
                 <a:tc>
                   <a:txBody>
-                    <a:bodyPr wrap="square"/>
+                    <a:bodyPr/>
                     <a:lstStyle/>
                     <a:p>
                       <a:pPr algn="l">
@@ -9206,6 +9521,15 @@
                     </a:p>
                   </a:txBody>
                   <a:tcPr marL="0" marR="95250" marT="57150" marB="57150" anchor="ctr">
+                    <a:lnT w="12700" cap="flat" cmpd="sng" algn="ctr">
+                      <a:solidFill>
+                        <a:srgbClr val="D8DEE6"/>
+                      </a:solidFill>
+                      <a:prstDash val="solid"/>
+                      <a:round/>
+                      <a:headEnd type="none" w="med" len="med"/>
+                      <a:tailEnd type="none" w="med" len="med"/>
+                    </a:lnT>
                     <a:lnB w="12700" cap="flat" cmpd="sng" algn="ctr">
                       <a:solidFill>
                         <a:srgbClr val="D8DEE6"/>
@@ -9218,7 +9542,7 @@
                 </a:tc>
                 <a:tc>
                   <a:txBody>
-                    <a:bodyPr wrap="square"/>
+                    <a:bodyPr/>
                     <a:lstStyle/>
                     <a:p>
                       <a:pPr algn="r">
@@ -9238,6 +9562,15 @@
                     </a:p>
                   </a:txBody>
                   <a:tcPr marL="95250" marR="0" marT="57150" marB="57150" anchor="ctr">
+                    <a:lnT w="12700" cap="flat" cmpd="sng" algn="ctr">
+                      <a:solidFill>
+                        <a:srgbClr val="D8DEE6"/>
+                      </a:solidFill>
+                      <a:prstDash val="solid"/>
+                      <a:round/>
+                      <a:headEnd type="none" w="med" len="med"/>
+                      <a:tailEnd type="none" w="med" len="med"/>
+                    </a:lnT>
                     <a:lnB w="12700" cap="flat" cmpd="sng" algn="ctr">
                       <a:solidFill>
                         <a:srgbClr val="D8DEE6"/>
@@ -9250,7 +9583,7 @@
                 </a:tc>
                 <a:tc>
                   <a:txBody>
-                    <a:bodyPr wrap="square"/>
+                    <a:bodyPr/>
                     <a:lstStyle/>
                     <a:p>
                       <a:pPr algn="r">
@@ -9270,6 +9603,15 @@
                     </a:p>
                   </a:txBody>
                   <a:tcPr marL="95250" marR="0" marT="57150" marB="57150" anchor="ctr">
+                    <a:lnT w="12700" cap="flat" cmpd="sng" algn="ctr">
+                      <a:solidFill>
+                        <a:srgbClr val="D8DEE6"/>
+                      </a:solidFill>
+                      <a:prstDash val="solid"/>
+                      <a:round/>
+                      <a:headEnd type="none" w="med" len="med"/>
+                      <a:tailEnd type="none" w="med" len="med"/>
+                    </a:lnT>
                     <a:lnB w="12700" cap="flat" cmpd="sng" algn="ctr">
                       <a:solidFill>
                         <a:srgbClr val="D8DEE6"/>
@@ -9282,7 +9624,7 @@
                 </a:tc>
                 <a:tc>
                   <a:txBody>
-                    <a:bodyPr wrap="square"/>
+                    <a:bodyPr/>
                     <a:lstStyle/>
                     <a:p>
                       <a:pPr algn="r">
@@ -9302,6 +9644,15 @@
                     </a:p>
                   </a:txBody>
                   <a:tcPr marL="95250" marR="0" marT="57150" marB="57150" anchor="ctr">
+                    <a:lnT w="12700" cap="flat" cmpd="sng" algn="ctr">
+                      <a:solidFill>
+                        <a:srgbClr val="D8DEE6"/>
+                      </a:solidFill>
+                      <a:prstDash val="solid"/>
+                      <a:round/>
+                      <a:headEnd type="none" w="med" len="med"/>
+                      <a:tailEnd type="none" w="med" len="med"/>
+                    </a:lnT>
                     <a:lnB w="12700" cap="flat" cmpd="sng" algn="ctr">
                       <a:solidFill>
                         <a:srgbClr val="D8DEE6"/>
@@ -9312,6 +9663,11 @@
                     </a:solidFill>
                   </a:tcPr>
                 </a:tc>
+                <a:extLst>
+                  <a:ext uri="{0D108BD9-81ED-4DB2-BD59-A6C34878D82A}">
+                    <a16:rowId xmlns:a16="http://schemas.microsoft.com/office/drawing/2014/main" val="10003"/>
+                  </a:ext>
+                </a:extLst>
               </a:tr>
             </a:tbl>
           </a:graphicData>
@@ -9334,7 +9690,7 @@
           <a:noFill/>
         </p:spPr>
         <p:txBody>
-          <a:bodyPr wrap="square" lIns="0" rIns="0" tIns="0" bIns="0" anchor="t">
+          <a:bodyPr wrap="square" lIns="0" tIns="0" rIns="0" bIns="0" anchor="t">
             <a:spAutoFit/>
           </a:bodyPr>
           <a:lstStyle/>
@@ -9399,6 +9755,7 @@
           <a:lstStyle/>
           <a:p>
             <a:pPr algn="ctr"/>
+            <a:endParaRPr/>
           </a:p>
         </p:txBody>
       </p:sp>
@@ -9443,6 +9800,7 @@
           <a:lstStyle/>
           <a:p>
             <a:pPr algn="ctr"/>
+            <a:endParaRPr/>
           </a:p>
         </p:txBody>
       </p:sp>
@@ -9463,7 +9821,7 @@
           <a:noFill/>
         </p:spPr>
         <p:txBody>
-          <a:bodyPr wrap="square" lIns="0" rIns="0" tIns="0" bIns="0" anchor="t">
+          <a:bodyPr wrap="square" lIns="0" tIns="0" rIns="0" bIns="0" anchor="t">
             <a:spAutoFit/>
           </a:bodyPr>
           <a:lstStyle/>
@@ -9498,7 +9856,7 @@
           <a:noFill/>
         </p:spPr>
         <p:txBody>
-          <a:bodyPr wrap="square" lIns="0" rIns="0" tIns="0" bIns="0" anchor="t">
+          <a:bodyPr wrap="square" lIns="0" tIns="0" rIns="0" bIns="0" anchor="t">
             <a:spAutoFit/>
           </a:bodyPr>
           <a:lstStyle/>
@@ -9529,7 +9887,7 @@
         <p:spPr>
           <a:xfrm>
             <a:off x="8648700" y="3619500"/>
-            <a:ext cx="2857500" cy="990600"/>
+            <a:ext cx="2857500" cy="1238250"/>
           </a:xfrm>
           <a:prstGeom prst="rect">
             <a:avLst/>
@@ -9563,6 +9921,7 @@
           <a:lstStyle/>
           <a:p>
             <a:pPr algn="ctr"/>
+            <a:endParaRPr/>
           </a:p>
         </p:txBody>
       </p:sp>
@@ -9583,7 +9942,7 @@
           <a:noFill/>
         </p:spPr>
         <p:txBody>
-          <a:bodyPr wrap="square" lIns="0" rIns="0" tIns="0" bIns="0" anchor="t">
+          <a:bodyPr wrap="square" lIns="0" tIns="0" rIns="0" bIns="0" anchor="t">
             <a:spAutoFit/>
           </a:bodyPr>
           <a:lstStyle/>
@@ -9618,7 +9977,7 @@
           <a:noFill/>
         </p:spPr>
         <p:txBody>
-          <a:bodyPr wrap="square" lIns="0" rIns="0" tIns="0" bIns="0" anchor="t">
+          <a:bodyPr wrap="square" lIns="0" tIns="0" rIns="0" bIns="0" anchor="t">
             <a:spAutoFit/>
           </a:bodyPr>
           <a:lstStyle/>
@@ -9681,6 +10040,7 @@
           <a:lstStyle/>
           <a:p>
             <a:pPr algn="ctr"/>
+            <a:endParaRPr/>
           </a:p>
         </p:txBody>
       </p:sp>
@@ -9701,7 +10061,7 @@
           <a:noFill/>
         </p:spPr>
         <p:txBody>
-          <a:bodyPr wrap="square" lIns="0" rIns="0" tIns="0" bIns="0" anchor="t">
+          <a:bodyPr wrap="square" lIns="0" tIns="0" rIns="0" bIns="0" anchor="t">
             <a:spAutoFit/>
           </a:bodyPr>
           <a:lstStyle/>
@@ -9728,7 +10088,7 @@
 </file>
 
 <file path=ppt/slides/slide7.xml><?xml version="1.0" encoding="utf-8"?>
-<p:sld xmlns:a="http://schemas.openxmlformats.org/drawingml/2006/main" xmlns:p="http://schemas.openxmlformats.org/presentationml/2006/main" xmlns:r="http://schemas.openxmlformats.org/officeDocument/2006/relationships">
+<p:sld xmlns:a="http://schemas.openxmlformats.org/drawingml/2006/main" xmlns:r="http://schemas.openxmlformats.org/officeDocument/2006/relationships" xmlns:p="http://schemas.openxmlformats.org/presentationml/2006/main">
   <p:cSld>
     <p:bg>
       <p:bgPr>
@@ -9744,7 +10104,14 @@
         <p:cNvGrpSpPr/>
         <p:nvPr/>
       </p:nvGrpSpPr>
-      <p:grpSpPr/>
+      <p:grpSpPr>
+        <a:xfrm>
+          <a:off x="0" y="0"/>
+          <a:ext cx="0" cy="0"/>
+          <a:chOff x="0" y="0"/>
+          <a:chExt cx="0" cy="0"/>
+        </a:xfrm>
+      </p:grpSpPr>
       <p:sp>
         <p:nvSpPr>
           <p:cNvPr id="2" name="TextBox 1"/>
@@ -9762,7 +10129,7 @@
           <a:noFill/>
         </p:spPr>
         <p:txBody>
-          <a:bodyPr wrap="square" lIns="0" rIns="0" tIns="0" bIns="0" anchor="t">
+          <a:bodyPr wrap="square" lIns="0" tIns="0" rIns="0" bIns="0" anchor="t">
             <a:spAutoFit/>
           </a:bodyPr>
           <a:lstStyle/>
@@ -9797,7 +10164,7 @@
           <a:noFill/>
         </p:spPr>
         <p:txBody>
-          <a:bodyPr wrap="square" lIns="0" rIns="0" tIns="0" bIns="0" anchor="t">
+          <a:bodyPr wrap="square" lIns="0" tIns="0" rIns="0" bIns="0" anchor="t">
             <a:spAutoFit/>
           </a:bodyPr>
           <a:lstStyle/>
@@ -9856,6 +10223,7 @@
           <a:lstStyle/>
           <a:p>
             <a:pPr algn="ctr"/>
+            <a:endParaRPr/>
           </a:p>
         </p:txBody>
       </p:sp>
@@ -9876,7 +10244,7 @@
           <a:noFill/>
         </p:spPr>
         <p:txBody>
-          <a:bodyPr wrap="square" lIns="0" rIns="0" tIns="0" bIns="0" anchor="t">
+          <a:bodyPr wrap="square" lIns="0" tIns="0" rIns="0" bIns="0" anchor="t">
             <a:spAutoFit/>
           </a:bodyPr>
           <a:lstStyle/>
@@ -9941,6 +10309,7 @@
           <a:lstStyle/>
           <a:p>
             <a:pPr algn="ctr"/>
+            <a:endParaRPr/>
           </a:p>
         </p:txBody>
       </p:sp>
@@ -9985,6 +10354,7 @@
           <a:lstStyle/>
           <a:p>
             <a:pPr algn="ctr"/>
+            <a:endParaRPr/>
           </a:p>
         </p:txBody>
       </p:sp>
@@ -10005,7 +10375,7 @@
           <a:noFill/>
         </p:spPr>
         <p:txBody>
-          <a:bodyPr wrap="square" lIns="0" rIns="0" tIns="0" bIns="0" anchor="t">
+          <a:bodyPr wrap="square" lIns="0" tIns="0" rIns="0" bIns="0" anchor="t">
             <a:spAutoFit/>
           </a:bodyPr>
           <a:lstStyle/>
@@ -10040,7 +10410,7 @@
           <a:noFill/>
         </p:spPr>
         <p:txBody>
-          <a:bodyPr wrap="square" lIns="0" rIns="0" tIns="0" bIns="0" anchor="t">
+          <a:bodyPr wrap="square" lIns="0" tIns="0" rIns="0" bIns="0" anchor="t">
             <a:spAutoFit/>
           </a:bodyPr>
           <a:lstStyle/>
@@ -10105,6 +10475,7 @@
           <a:lstStyle/>
           <a:p>
             <a:pPr algn="ctr"/>
+            <a:endParaRPr/>
           </a:p>
         </p:txBody>
       </p:sp>
@@ -10149,6 +10520,7 @@
           <a:lstStyle/>
           <a:p>
             <a:pPr algn="ctr"/>
+            <a:endParaRPr/>
           </a:p>
         </p:txBody>
       </p:sp>
@@ -10169,7 +10541,7 @@
           <a:noFill/>
         </p:spPr>
         <p:txBody>
-          <a:bodyPr wrap="square" lIns="0" rIns="0" tIns="0" bIns="0" anchor="t">
+          <a:bodyPr wrap="square" lIns="0" tIns="0" rIns="0" bIns="0" anchor="t">
             <a:spAutoFit/>
           </a:bodyPr>
           <a:lstStyle/>
@@ -10204,7 +10576,7 @@
           <a:noFill/>
         </p:spPr>
         <p:txBody>
-          <a:bodyPr wrap="square" lIns="0" rIns="0" tIns="0" bIns="0" anchor="t">
+          <a:bodyPr wrap="square" lIns="0" tIns="0" rIns="0" bIns="0" anchor="t">
             <a:spAutoFit/>
           </a:bodyPr>
           <a:lstStyle/>
@@ -10269,6 +10641,7 @@
           <a:lstStyle/>
           <a:p>
             <a:pPr algn="ctr"/>
+            <a:endParaRPr/>
           </a:p>
         </p:txBody>
       </p:sp>
@@ -10313,6 +10686,7 @@
           <a:lstStyle/>
           <a:p>
             <a:pPr algn="ctr"/>
+            <a:endParaRPr/>
           </a:p>
         </p:txBody>
       </p:sp>
@@ -10333,7 +10707,7 @@
           <a:noFill/>
         </p:spPr>
         <p:txBody>
-          <a:bodyPr wrap="square" lIns="0" rIns="0" tIns="0" bIns="0" anchor="t">
+          <a:bodyPr wrap="square" lIns="0" tIns="0" rIns="0" bIns="0" anchor="t">
             <a:spAutoFit/>
           </a:bodyPr>
           <a:lstStyle/>
@@ -10368,7 +10742,7 @@
           <a:noFill/>
         </p:spPr>
         <p:txBody>
-          <a:bodyPr wrap="square" lIns="0" rIns="0" tIns="0" bIns="0" anchor="t">
+          <a:bodyPr wrap="square" lIns="0" tIns="0" rIns="0" bIns="0" anchor="t">
             <a:spAutoFit/>
           </a:bodyPr>
           <a:lstStyle/>
@@ -10433,6 +10807,7 @@
           <a:lstStyle/>
           <a:p>
             <a:pPr algn="ctr"/>
+            <a:endParaRPr/>
           </a:p>
         </p:txBody>
       </p:sp>
@@ -10477,6 +10852,7 @@
           <a:lstStyle/>
           <a:p>
             <a:pPr algn="ctr"/>
+            <a:endParaRPr/>
           </a:p>
         </p:txBody>
       </p:sp>
@@ -10497,7 +10873,7 @@
           <a:noFill/>
         </p:spPr>
         <p:txBody>
-          <a:bodyPr wrap="square" lIns="0" rIns="0" tIns="0" bIns="0" anchor="t">
+          <a:bodyPr wrap="square" lIns="0" tIns="0" rIns="0" bIns="0" anchor="t">
             <a:spAutoFit/>
           </a:bodyPr>
           <a:lstStyle/>
@@ -10532,7 +10908,7 @@
           <a:noFill/>
         </p:spPr>
         <p:txBody>
-          <a:bodyPr wrap="square" lIns="0" rIns="0" tIns="0" bIns="0" anchor="t">
+          <a:bodyPr wrap="square" lIns="0" tIns="0" rIns="0" bIns="0" anchor="t">
             <a:spAutoFit/>
           </a:bodyPr>
           <a:lstStyle/>
@@ -10595,6 +10971,7 @@
           <a:lstStyle/>
           <a:p>
             <a:pPr algn="ctr"/>
+            <a:endParaRPr/>
           </a:p>
         </p:txBody>
       </p:sp>
@@ -10615,7 +10992,7 @@
           <a:noFill/>
         </p:spPr>
         <p:txBody>
-          <a:bodyPr wrap="square" lIns="0" rIns="0" tIns="0" bIns="0" anchor="t">
+          <a:bodyPr wrap="square" lIns="0" tIns="0" rIns="0" bIns="0" anchor="t">
             <a:spAutoFit/>
           </a:bodyPr>
           <a:lstStyle/>
@@ -10642,7 +11019,7 @@
 </file>
 
 <file path=ppt/slides/slide8.xml><?xml version="1.0" encoding="utf-8"?>
-<p:sld xmlns:a="http://schemas.openxmlformats.org/drawingml/2006/main" xmlns:p="http://schemas.openxmlformats.org/presentationml/2006/main" xmlns:r="http://schemas.openxmlformats.org/officeDocument/2006/relationships">
+<p:sld xmlns:a="http://schemas.openxmlformats.org/drawingml/2006/main" xmlns:r="http://schemas.openxmlformats.org/officeDocument/2006/relationships" xmlns:p="http://schemas.openxmlformats.org/presentationml/2006/main">
   <p:cSld>
     <p:bg>
       <p:bgPr>
@@ -10658,7 +11035,14 @@
         <p:cNvGrpSpPr/>
         <p:nvPr/>
       </p:nvGrpSpPr>
-      <p:grpSpPr/>
+      <p:grpSpPr>
+        <a:xfrm>
+          <a:off x="0" y="0"/>
+          <a:ext cx="0" cy="0"/>
+          <a:chOff x="0" y="0"/>
+          <a:chExt cx="0" cy="0"/>
+        </a:xfrm>
+      </p:grpSpPr>
       <p:sp>
         <p:nvSpPr>
           <p:cNvPr id="2" name="TextBox 1"/>
@@ -10676,7 +11060,7 @@
           <a:noFill/>
         </p:spPr>
         <p:txBody>
-          <a:bodyPr wrap="square" lIns="0" rIns="0" tIns="0" bIns="0" anchor="t">
+          <a:bodyPr wrap="square" lIns="0" tIns="0" rIns="0" bIns="0" anchor="t">
             <a:spAutoFit/>
           </a:bodyPr>
           <a:lstStyle/>
@@ -10711,7 +11095,7 @@
           <a:noFill/>
         </p:spPr>
         <p:txBody>
-          <a:bodyPr wrap="square" lIns="0" rIns="0" tIns="0" bIns="0" anchor="t">
+          <a:bodyPr wrap="square" lIns="0" tIns="0" rIns="0" bIns="0" anchor="t">
             <a:spAutoFit/>
           </a:bodyPr>
           <a:lstStyle/>
@@ -10770,6 +11154,7 @@
           <a:lstStyle/>
           <a:p>
             <a:pPr algn="ctr"/>
+            <a:endParaRPr/>
           </a:p>
         </p:txBody>
       </p:sp>
@@ -10790,7 +11175,7 @@
           <a:noFill/>
         </p:spPr>
         <p:txBody>
-          <a:bodyPr wrap="square" lIns="0" rIns="0" tIns="0" bIns="0" anchor="t">
+          <a:bodyPr wrap="square" lIns="0" tIns="0" rIns="0" bIns="0" anchor="t">
             <a:spAutoFit/>
           </a:bodyPr>
           <a:lstStyle/>
@@ -10831,14 +11216,32 @@
                 <a:tableStyleId>{5C22544A-7EE6-4342-B048-85BDC9FD1C3A}</a:tableStyleId>
               </a:tblPr>
               <a:tblGrid>
-                <a:gridCol w="3676650"/>
-                <a:gridCol w="2705100"/>
-                <a:gridCol w="4438650"/>
+                <a:gridCol w="3676650">
+                  <a:extLst>
+                    <a:ext uri="{9D8B030D-6E8A-4147-A177-3AD203B41FA5}">
+                      <a16:colId xmlns:a16="http://schemas.microsoft.com/office/drawing/2014/main" val="20000"/>
+                    </a:ext>
+                  </a:extLst>
+                </a:gridCol>
+                <a:gridCol w="2705100">
+                  <a:extLst>
+                    <a:ext uri="{9D8B030D-6E8A-4147-A177-3AD203B41FA5}">
+                      <a16:colId xmlns:a16="http://schemas.microsoft.com/office/drawing/2014/main" val="20001"/>
+                    </a:ext>
+                  </a:extLst>
+                </a:gridCol>
+                <a:gridCol w="4438650">
+                  <a:extLst>
+                    <a:ext uri="{9D8B030D-6E8A-4147-A177-3AD203B41FA5}">
+                      <a16:colId xmlns:a16="http://schemas.microsoft.com/office/drawing/2014/main" val="20002"/>
+                    </a:ext>
+                  </a:extLst>
+                </a:gridCol>
               </a:tblGrid>
               <a:tr h="476250">
                 <a:tc>
                   <a:txBody>
-                    <a:bodyPr wrap="square"/>
+                    <a:bodyPr/>
                     <a:lstStyle/>
                     <a:p>
                       <a:pPr algn="l">
@@ -10870,7 +11273,7 @@
                 </a:tc>
                 <a:tc>
                   <a:txBody>
-                    <a:bodyPr wrap="square"/>
+                    <a:bodyPr/>
                     <a:lstStyle/>
                     <a:p>
                       <a:pPr algn="l">
@@ -10902,7 +11305,7 @@
                 </a:tc>
                 <a:tc>
                   <a:txBody>
-                    <a:bodyPr wrap="square"/>
+                    <a:bodyPr/>
                     <a:lstStyle/>
                     <a:p>
                       <a:pPr algn="l">
@@ -10932,11 +11335,16 @@
                     </a:solidFill>
                   </a:tcPr>
                 </a:tc>
+                <a:extLst>
+                  <a:ext uri="{0D108BD9-81ED-4DB2-BD59-A6C34878D82A}">
+                    <a16:rowId xmlns:a16="http://schemas.microsoft.com/office/drawing/2014/main" val="10000"/>
+                  </a:ext>
+                </a:extLst>
               </a:tr>
               <a:tr h="514350">
                 <a:tc>
                   <a:txBody>
-                    <a:bodyPr wrap="square"/>
+                    <a:bodyPr/>
                     <a:lstStyle/>
                     <a:p>
                       <a:pPr algn="l">
@@ -10956,6 +11364,15 @@
                     </a:p>
                   </a:txBody>
                   <a:tcPr marL="0" marR="95250" marT="57150" marB="57150" anchor="ctr">
+                    <a:lnT w="25400" cap="flat" cmpd="sng" algn="ctr">
+                      <a:solidFill>
+                        <a:srgbClr val="1F3A5F"/>
+                      </a:solidFill>
+                      <a:prstDash val="solid"/>
+                      <a:round/>
+                      <a:headEnd type="none" w="med" len="med"/>
+                      <a:tailEnd type="none" w="med" len="med"/>
+                    </a:lnT>
                     <a:lnB w="12700" cap="flat" cmpd="sng" algn="ctr">
                       <a:solidFill>
                         <a:srgbClr val="D8DEE6"/>
@@ -10968,7 +11385,7 @@
                 </a:tc>
                 <a:tc>
                   <a:txBody>
-                    <a:bodyPr wrap="square"/>
+                    <a:bodyPr/>
                     <a:lstStyle/>
                     <a:p>
                       <a:pPr algn="l">
@@ -10988,6 +11405,15 @@
                     </a:p>
                   </a:txBody>
                   <a:tcPr marL="0" marR="95250" marT="57150" marB="57150" anchor="ctr">
+                    <a:lnT w="25400" cap="flat" cmpd="sng" algn="ctr">
+                      <a:solidFill>
+                        <a:srgbClr val="1F3A5F"/>
+                      </a:solidFill>
+                      <a:prstDash val="solid"/>
+                      <a:round/>
+                      <a:headEnd type="none" w="med" len="med"/>
+                      <a:tailEnd type="none" w="med" len="med"/>
+                    </a:lnT>
                     <a:lnB w="12700" cap="flat" cmpd="sng" algn="ctr">
                       <a:solidFill>
                         <a:srgbClr val="D8DEE6"/>
@@ -11000,7 +11426,7 @@
                 </a:tc>
                 <a:tc>
                   <a:txBody>
-                    <a:bodyPr wrap="square"/>
+                    <a:bodyPr/>
                     <a:lstStyle/>
                     <a:p>
                       <a:pPr algn="l">
@@ -11020,6 +11446,15 @@
                     </a:p>
                   </a:txBody>
                   <a:tcPr marL="0" marR="95250" marT="57150" marB="57150" anchor="ctr">
+                    <a:lnT w="25400" cap="flat" cmpd="sng" algn="ctr">
+                      <a:solidFill>
+                        <a:srgbClr val="1F3A5F"/>
+                      </a:solidFill>
+                      <a:prstDash val="solid"/>
+                      <a:round/>
+                      <a:headEnd type="none" w="med" len="med"/>
+                      <a:tailEnd type="none" w="med" len="med"/>
+                    </a:lnT>
                     <a:lnB w="12700" cap="flat" cmpd="sng" algn="ctr">
                       <a:solidFill>
                         <a:srgbClr val="D8DEE6"/>
@@ -11030,11 +11465,16 @@
                     </a:solidFill>
                   </a:tcPr>
                 </a:tc>
+                <a:extLst>
+                  <a:ext uri="{0D108BD9-81ED-4DB2-BD59-A6C34878D82A}">
+                    <a16:rowId xmlns:a16="http://schemas.microsoft.com/office/drawing/2014/main" val="10001"/>
+                  </a:ext>
+                </a:extLst>
               </a:tr>
               <a:tr h="514350">
                 <a:tc>
                   <a:txBody>
-                    <a:bodyPr wrap="square"/>
+                    <a:bodyPr/>
                     <a:lstStyle/>
                     <a:p>
                       <a:pPr algn="l">
@@ -11054,6 +11494,15 @@
                     </a:p>
                   </a:txBody>
                   <a:tcPr marL="0" marR="95250" marT="57150" marB="57150" anchor="ctr">
+                    <a:lnT w="12700" cap="flat" cmpd="sng" algn="ctr">
+                      <a:solidFill>
+                        <a:srgbClr val="D8DEE6"/>
+                      </a:solidFill>
+                      <a:prstDash val="solid"/>
+                      <a:round/>
+                      <a:headEnd type="none" w="med" len="med"/>
+                      <a:tailEnd type="none" w="med" len="med"/>
+                    </a:lnT>
                     <a:lnB w="12700" cap="flat" cmpd="sng" algn="ctr">
                       <a:solidFill>
                         <a:srgbClr val="D8DEE6"/>
@@ -11066,7 +11515,7 @@
                 </a:tc>
                 <a:tc>
                   <a:txBody>
-                    <a:bodyPr wrap="square"/>
+                    <a:bodyPr/>
                     <a:lstStyle/>
                     <a:p>
                       <a:pPr algn="l">
@@ -11086,6 +11535,15 @@
                     </a:p>
                   </a:txBody>
                   <a:tcPr marL="0" marR="95250" marT="57150" marB="57150" anchor="ctr">
+                    <a:lnT w="12700" cap="flat" cmpd="sng" algn="ctr">
+                      <a:solidFill>
+                        <a:srgbClr val="D8DEE6"/>
+                      </a:solidFill>
+                      <a:prstDash val="solid"/>
+                      <a:round/>
+                      <a:headEnd type="none" w="med" len="med"/>
+                      <a:tailEnd type="none" w="med" len="med"/>
+                    </a:lnT>
                     <a:lnB w="12700" cap="flat" cmpd="sng" algn="ctr">
                       <a:solidFill>
                         <a:srgbClr val="D8DEE6"/>
@@ -11098,7 +11556,7 @@
                 </a:tc>
                 <a:tc>
                   <a:txBody>
-                    <a:bodyPr wrap="square"/>
+                    <a:bodyPr/>
                     <a:lstStyle/>
                     <a:p>
                       <a:pPr algn="l">
@@ -11118,6 +11576,15 @@
                     </a:p>
                   </a:txBody>
                   <a:tcPr marL="0" marR="95250" marT="57150" marB="57150" anchor="ctr">
+                    <a:lnT w="12700" cap="flat" cmpd="sng" algn="ctr">
+                      <a:solidFill>
+                        <a:srgbClr val="D8DEE6"/>
+                      </a:solidFill>
+                      <a:prstDash val="solid"/>
+                      <a:round/>
+                      <a:headEnd type="none" w="med" len="med"/>
+                      <a:tailEnd type="none" w="med" len="med"/>
+                    </a:lnT>
                     <a:lnB w="12700" cap="flat" cmpd="sng" algn="ctr">
                       <a:solidFill>
                         <a:srgbClr val="D8DEE6"/>
@@ -11128,6 +11595,11 @@
                     </a:solidFill>
                   </a:tcPr>
                 </a:tc>
+                <a:extLst>
+                  <a:ext uri="{0D108BD9-81ED-4DB2-BD59-A6C34878D82A}">
+                    <a16:rowId xmlns:a16="http://schemas.microsoft.com/office/drawing/2014/main" val="10002"/>
+                  </a:ext>
+                </a:extLst>
               </a:tr>
             </a:tbl>
           </a:graphicData>
@@ -11174,7 +11646,7 @@
           <a:noFill/>
         </p:spPr>
         <p:txBody>
-          <a:bodyPr wrap="square" lIns="0" rIns="0" tIns="0" bIns="0" anchor="t">
+          <a:bodyPr wrap="square" lIns="0" tIns="0" rIns="0" bIns="0" anchor="t">
             <a:spAutoFit/>
           </a:bodyPr>
           <a:lstStyle/>
@@ -11239,6 +11711,7 @@
           <a:lstStyle/>
           <a:p>
             <a:pPr algn="ctr"/>
+            <a:endParaRPr/>
           </a:p>
         </p:txBody>
       </p:sp>
@@ -11283,6 +11756,7 @@
           <a:lstStyle/>
           <a:p>
             <a:pPr algn="ctr"/>
+            <a:endParaRPr/>
           </a:p>
         </p:txBody>
       </p:sp>
@@ -11303,7 +11777,7 @@
           <a:noFill/>
         </p:spPr>
         <p:txBody>
-          <a:bodyPr wrap="square" lIns="0" rIns="0" tIns="0" bIns="0" anchor="t">
+          <a:bodyPr wrap="square" lIns="0" tIns="0" rIns="0" bIns="0" anchor="t">
             <a:spAutoFit/>
           </a:bodyPr>
           <a:lstStyle/>
@@ -11338,7 +11812,7 @@
           <a:noFill/>
         </p:spPr>
         <p:txBody>
-          <a:bodyPr wrap="square" lIns="0" rIns="0" tIns="0" bIns="0" anchor="t">
+          <a:bodyPr wrap="square" lIns="0" tIns="0" rIns="0" bIns="0" anchor="t">
             <a:spAutoFit/>
           </a:bodyPr>
           <a:lstStyle/>
@@ -11401,6 +11875,7 @@
           <a:lstStyle/>
           <a:p>
             <a:pPr algn="ctr"/>
+            <a:endParaRPr/>
           </a:p>
         </p:txBody>
       </p:sp>
@@ -11421,7 +11896,7 @@
           <a:noFill/>
         </p:spPr>
         <p:txBody>
-          <a:bodyPr wrap="square" lIns="0" rIns="0" tIns="0" bIns="0" anchor="t">
+          <a:bodyPr wrap="square" lIns="0" tIns="0" rIns="0" bIns="0" anchor="t">
             <a:spAutoFit/>
           </a:bodyPr>
           <a:lstStyle/>
@@ -11448,7 +11923,7 @@
 </file>
 
 <file path=ppt/slides/slide9.xml><?xml version="1.0" encoding="utf-8"?>
-<p:sld xmlns:a="http://schemas.openxmlformats.org/drawingml/2006/main" xmlns:p="http://schemas.openxmlformats.org/presentationml/2006/main" xmlns:r="http://schemas.openxmlformats.org/officeDocument/2006/relationships">
+<p:sld xmlns:a="http://schemas.openxmlformats.org/drawingml/2006/main" xmlns:r="http://schemas.openxmlformats.org/officeDocument/2006/relationships" xmlns:p="http://schemas.openxmlformats.org/presentationml/2006/main">
   <p:cSld>
     <p:bg>
       <p:bgPr>
@@ -11464,7 +11939,14 @@
         <p:cNvGrpSpPr/>
         <p:nvPr/>
       </p:nvGrpSpPr>
-      <p:grpSpPr/>
+      <p:grpSpPr>
+        <a:xfrm>
+          <a:off x="0" y="0"/>
+          <a:ext cx="0" cy="0"/>
+          <a:chOff x="0" y="0"/>
+          <a:chExt cx="0" cy="0"/>
+        </a:xfrm>
+      </p:grpSpPr>
       <p:sp>
         <p:nvSpPr>
           <p:cNvPr id="2" name="TextBox 1"/>
@@ -11482,7 +11964,7 @@
           <a:noFill/>
         </p:spPr>
         <p:txBody>
-          <a:bodyPr wrap="square" lIns="0" rIns="0" tIns="0" bIns="0" anchor="t">
+          <a:bodyPr wrap="square" lIns="0" tIns="0" rIns="0" bIns="0" anchor="t">
             <a:spAutoFit/>
           </a:bodyPr>
           <a:lstStyle/>
@@ -11517,7 +11999,7 @@
           <a:noFill/>
         </p:spPr>
         <p:txBody>
-          <a:bodyPr wrap="square" lIns="0" rIns="0" tIns="0" bIns="0" anchor="t">
+          <a:bodyPr wrap="square" lIns="0" tIns="0" rIns="0" bIns="0" anchor="t">
             <a:spAutoFit/>
           </a:bodyPr>
           <a:lstStyle/>
@@ -11576,6 +12058,7 @@
           <a:lstStyle/>
           <a:p>
             <a:pPr algn="ctr"/>
+            <a:endParaRPr/>
           </a:p>
         </p:txBody>
       </p:sp>
@@ -11596,7 +12079,7 @@
           <a:noFill/>
         </p:spPr>
         <p:txBody>
-          <a:bodyPr wrap="square" lIns="0" rIns="0" tIns="0" bIns="0" anchor="t">
+          <a:bodyPr wrap="square" lIns="0" tIns="0" rIns="0" bIns="0" anchor="t">
             <a:spAutoFit/>
           </a:bodyPr>
           <a:lstStyle/>
@@ -11635,7 +12118,7 @@
           <a:noFill/>
         </p:spPr>
         <p:txBody>
-          <a:bodyPr wrap="square" lIns="0" rIns="0" tIns="0" bIns="0" anchor="t">
+          <a:bodyPr wrap="square" lIns="0" tIns="0" rIns="0" bIns="0" anchor="t">
             <a:spAutoFit/>
           </a:bodyPr>
           <a:lstStyle/>
@@ -11694,6 +12177,7 @@
           <a:lstStyle/>
           <a:p>
             <a:pPr algn="ctr"/>
+            <a:endParaRPr/>
           </a:p>
         </p:txBody>
       </p:sp>
@@ -11714,7 +12198,7 @@
           <a:noFill/>
         </p:spPr>
         <p:txBody>
-          <a:bodyPr wrap="square" lIns="0" rIns="0" tIns="0" bIns="0" anchor="t">
+          <a:bodyPr wrap="square" lIns="0" tIns="0" rIns="0" bIns="0" anchor="t">
             <a:spAutoFit/>
           </a:bodyPr>
           <a:lstStyle/>
@@ -11777,6 +12261,7 @@
           <a:lstStyle/>
           <a:p>
             <a:pPr algn="ctr"/>
+            <a:endParaRPr/>
           </a:p>
         </p:txBody>
       </p:sp>
@@ -11797,7 +12282,7 @@
           <a:noFill/>
         </p:spPr>
         <p:txBody>
-          <a:bodyPr wrap="square" lIns="0" rIns="0" tIns="0" bIns="0" anchor="t">
+          <a:bodyPr wrap="square" lIns="0" tIns="0" rIns="0" bIns="0" anchor="t">
             <a:spAutoFit/>
           </a:bodyPr>
           <a:lstStyle/>
@@ -11860,6 +12345,7 @@
           <a:lstStyle/>
           <a:p>
             <a:pPr algn="ctr"/>
+            <a:endParaRPr/>
           </a:p>
         </p:txBody>
       </p:sp>
@@ -11880,7 +12366,7 @@
           <a:noFill/>
         </p:spPr>
         <p:txBody>
-          <a:bodyPr wrap="square" lIns="0" rIns="0" tIns="0" bIns="0" anchor="t">
+          <a:bodyPr wrap="square" lIns="0" tIns="0" rIns="0" bIns="0" anchor="t">
             <a:spAutoFit/>
           </a:bodyPr>
           <a:lstStyle/>
@@ -11943,6 +12429,7 @@
           <a:lstStyle/>
           <a:p>
             <a:pPr algn="ctr"/>
+            <a:endParaRPr/>
           </a:p>
         </p:txBody>
       </p:sp>
@@ -11963,7 +12450,7 @@
           <a:noFill/>
         </p:spPr>
         <p:txBody>
-          <a:bodyPr wrap="square" lIns="0" rIns="0" tIns="0" bIns="0" anchor="t">
+          <a:bodyPr wrap="square" lIns="0" tIns="0" rIns="0" bIns="0" anchor="t">
             <a:spAutoFit/>
           </a:bodyPr>
           <a:lstStyle/>
@@ -12026,6 +12513,7 @@
           <a:lstStyle/>
           <a:p>
             <a:pPr algn="ctr"/>
+            <a:endParaRPr/>
           </a:p>
         </p:txBody>
       </p:sp>
@@ -12046,7 +12534,7 @@
           <a:noFill/>
         </p:spPr>
         <p:txBody>
-          <a:bodyPr wrap="square" lIns="0" rIns="0" tIns="0" bIns="0" anchor="t">
+          <a:bodyPr wrap="square" lIns="0" tIns="0" rIns="0" bIns="0" anchor="t">
             <a:spAutoFit/>
           </a:bodyPr>
           <a:lstStyle/>
@@ -12085,7 +12573,7 @@
           <a:noFill/>
         </p:spPr>
         <p:txBody>
-          <a:bodyPr wrap="square" lIns="0" rIns="0" tIns="0" bIns="0" anchor="t">
+          <a:bodyPr wrap="square" lIns="0" tIns="0" rIns="0" bIns="0" anchor="t">
             <a:spAutoFit/>
           </a:bodyPr>
           <a:lstStyle/>
@@ -12144,6 +12632,7 @@
           <a:lstStyle/>
           <a:p>
             <a:pPr algn="ctr"/>
+            <a:endParaRPr/>
           </a:p>
         </p:txBody>
       </p:sp>
@@ -12164,7 +12653,7 @@
           <a:noFill/>
         </p:spPr>
         <p:txBody>
-          <a:bodyPr wrap="square" lIns="0" rIns="0" tIns="0" bIns="0" anchor="t">
+          <a:bodyPr wrap="square" lIns="0" tIns="0" rIns="0" bIns="0" anchor="t">
             <a:spAutoFit/>
           </a:bodyPr>
           <a:lstStyle/>
@@ -12227,6 +12716,7 @@
           <a:lstStyle/>
           <a:p>
             <a:pPr algn="ctr"/>
+            <a:endParaRPr/>
           </a:p>
         </p:txBody>
       </p:sp>
@@ -12247,7 +12737,7 @@
           <a:noFill/>
         </p:spPr>
         <p:txBody>
-          <a:bodyPr wrap="square" lIns="0" rIns="0" tIns="0" bIns="0" anchor="t">
+          <a:bodyPr wrap="square" lIns="0" tIns="0" rIns="0" bIns="0" anchor="t">
             <a:spAutoFit/>
           </a:bodyPr>
           <a:lstStyle/>
@@ -12310,6 +12800,7 @@
           <a:lstStyle/>
           <a:p>
             <a:pPr algn="ctr"/>
+            <a:endParaRPr/>
           </a:p>
         </p:txBody>
       </p:sp>
@@ -12330,7 +12821,7 @@
           <a:noFill/>
         </p:spPr>
         <p:txBody>
-          <a:bodyPr wrap="square" lIns="0" rIns="0" tIns="0" bIns="0" anchor="t">
+          <a:bodyPr wrap="square" lIns="0" tIns="0" rIns="0" bIns="0" anchor="t">
             <a:spAutoFit/>
           </a:bodyPr>
           <a:lstStyle/>
@@ -12393,6 +12884,7 @@
           <a:lstStyle/>
           <a:p>
             <a:pPr algn="ctr"/>
+            <a:endParaRPr/>
           </a:p>
         </p:txBody>
       </p:sp>
@@ -12413,7 +12905,7 @@
           <a:noFill/>
         </p:spPr>
         <p:txBody>
-          <a:bodyPr wrap="square" lIns="0" rIns="0" tIns="0" bIns="0" anchor="t">
+          <a:bodyPr wrap="square" lIns="0" tIns="0" rIns="0" bIns="0" anchor="t">
             <a:spAutoFit/>
           </a:bodyPr>
           <a:lstStyle/>
@@ -12476,6 +12968,7 @@
           <a:lstStyle/>
           <a:p>
             <a:pPr algn="ctr"/>
+            <a:endParaRPr/>
           </a:p>
         </p:txBody>
       </p:sp>
@@ -12496,7 +12989,7 @@
           <a:noFill/>
         </p:spPr>
         <p:txBody>
-          <a:bodyPr wrap="square" lIns="0" rIns="0" tIns="0" bIns="0" anchor="t">
+          <a:bodyPr wrap="square" lIns="0" tIns="0" rIns="0" bIns="0" anchor="t">
             <a:spAutoFit/>
           </a:bodyPr>
           <a:lstStyle/>
@@ -12535,7 +13028,7 @@
           <a:noFill/>
         </p:spPr>
         <p:txBody>
-          <a:bodyPr wrap="square" lIns="0" rIns="0" tIns="0" bIns="0" anchor="t">
+          <a:bodyPr wrap="square" lIns="0" tIns="0" rIns="0" bIns="0" anchor="t">
             <a:spAutoFit/>
           </a:bodyPr>
           <a:lstStyle/>
@@ -12594,6 +13087,7 @@
           <a:lstStyle/>
           <a:p>
             <a:pPr algn="ctr"/>
+            <a:endParaRPr/>
           </a:p>
         </p:txBody>
       </p:sp>
@@ -12614,7 +13108,7 @@
           <a:noFill/>
         </p:spPr>
         <p:txBody>
-          <a:bodyPr wrap="square" lIns="0" rIns="0" tIns="0" bIns="0" anchor="t">
+          <a:bodyPr wrap="square" lIns="0" tIns="0" rIns="0" bIns="0" anchor="t">
             <a:spAutoFit/>
           </a:bodyPr>
           <a:lstStyle/>
@@ -12677,6 +13171,7 @@
           <a:lstStyle/>
           <a:p>
             <a:pPr algn="ctr"/>
+            <a:endParaRPr/>
           </a:p>
         </p:txBody>
       </p:sp>
@@ -12697,7 +13192,7 @@
           <a:noFill/>
         </p:spPr>
         <p:txBody>
-          <a:bodyPr wrap="square" lIns="0" rIns="0" tIns="0" bIns="0" anchor="t">
+          <a:bodyPr wrap="square" lIns="0" tIns="0" rIns="0" bIns="0" anchor="t">
             <a:spAutoFit/>
           </a:bodyPr>
           <a:lstStyle/>
@@ -12760,6 +13255,7 @@
           <a:lstStyle/>
           <a:p>
             <a:pPr algn="ctr"/>
+            <a:endParaRPr/>
           </a:p>
         </p:txBody>
       </p:sp>
@@ -12780,7 +13276,7 @@
           <a:noFill/>
         </p:spPr>
         <p:txBody>
-          <a:bodyPr wrap="square" lIns="0" rIns="0" tIns="0" bIns="0" anchor="t">
+          <a:bodyPr wrap="square" lIns="0" tIns="0" rIns="0" bIns="0" anchor="t">
             <a:spAutoFit/>
           </a:bodyPr>
           <a:lstStyle/>
@@ -12843,6 +13339,7 @@
           <a:lstStyle/>
           <a:p>
             <a:pPr algn="ctr"/>
+            <a:endParaRPr/>
           </a:p>
         </p:txBody>
       </p:sp>
@@ -12863,7 +13360,7 @@
           <a:noFill/>
         </p:spPr>
         <p:txBody>
-          <a:bodyPr wrap="square" lIns="0" rIns="0" tIns="0" bIns="0" anchor="t">
+          <a:bodyPr wrap="square" lIns="0" tIns="0" rIns="0" bIns="0" anchor="t">
             <a:spAutoFit/>
           </a:bodyPr>
           <a:lstStyle/>
@@ -12926,6 +13423,7 @@
           <a:lstStyle/>
           <a:p>
             <a:pPr algn="ctr"/>
+            <a:endParaRPr/>
           </a:p>
         </p:txBody>
       </p:sp>
@@ -12946,7 +13444,7 @@
           <a:noFill/>
         </p:spPr>
         <p:txBody>
-          <a:bodyPr wrap="square" lIns="0" rIns="0" tIns="0" bIns="0" anchor="t">
+          <a:bodyPr wrap="square" lIns="0" tIns="0" rIns="0" bIns="0" anchor="t">
             <a:spAutoFit/>
           </a:bodyPr>
           <a:lstStyle/>
@@ -13009,6 +13507,7 @@
           <a:lstStyle/>
           <a:p>
             <a:pPr algn="ctr"/>
+            <a:endParaRPr/>
           </a:p>
         </p:txBody>
       </p:sp>
@@ -13029,7 +13528,7 @@
           <a:noFill/>
         </p:spPr>
         <p:txBody>
-          <a:bodyPr wrap="square" lIns="0" rIns="0" tIns="0" bIns="0" anchor="t">
+          <a:bodyPr wrap="square" lIns="0" tIns="0" rIns="0" bIns="0" anchor="t">
             <a:spAutoFit/>
           </a:bodyPr>
           <a:lstStyle/>

</xml_diff>